<commit_message>
Update R workshop slides to align with updated PDF (based on HEAbespoke slides)
</commit_message>
<xml_diff>
--- a/slides/workshopslides_RforRAP.pptx
+++ b/slides/workshopslides_RforRAP.pptx
@@ -7,15 +7,16 @@
   <p:sldIdLst>
     <p:sldId id="256" r:id="rId2"/>
     <p:sldId id="257" r:id="rId3"/>
-    <p:sldId id="272" r:id="rId4"/>
-    <p:sldId id="268" r:id="rId5"/>
-    <p:sldId id="271" r:id="rId6"/>
-    <p:sldId id="273" r:id="rId7"/>
-    <p:sldId id="269" r:id="rId8"/>
-    <p:sldId id="270" r:id="rId9"/>
-    <p:sldId id="275" r:id="rId10"/>
-    <p:sldId id="261" r:id="rId11"/>
-    <p:sldId id="274" r:id="rId12"/>
+    <p:sldId id="277" r:id="rId4"/>
+    <p:sldId id="272" r:id="rId5"/>
+    <p:sldId id="268" r:id="rId6"/>
+    <p:sldId id="271" r:id="rId7"/>
+    <p:sldId id="273" r:id="rId8"/>
+    <p:sldId id="269" r:id="rId9"/>
+    <p:sldId id="270" r:id="rId10"/>
+    <p:sldId id="275" r:id="rId11"/>
+    <p:sldId id="261" r:id="rId12"/>
+    <p:sldId id="276" r:id="rId13"/>
   </p:sldIdLst>
   <p:sldSz cx="12192000" cy="6858000"/>
   <p:notesSz cx="6858000" cy="9144000"/>
@@ -125,6 +126,7 @@
         <p14:section name="Introduction" id="{00ECBA4F-322D-4FBD-9D49-C8877E291C4E}">
           <p14:sldIdLst>
             <p14:sldId id="257"/>
+            <p14:sldId id="277"/>
             <p14:sldId id="272"/>
             <p14:sldId id="268"/>
             <p14:sldId id="271"/>
@@ -137,11 +139,7 @@
         <p14:section name="Getting set up" id="{DB08BAA9-0D66-49AE-8CD1-F21BFB1D8F82}">
           <p14:sldIdLst>
             <p14:sldId id="261"/>
-          </p14:sldIdLst>
-        </p14:section>
-        <p14:section name="R studio" id="{9FE46D6A-6AF2-4930-8E51-DCD53BE7A578}">
-          <p14:sldIdLst>
-            <p14:sldId id="274"/>
+            <p14:sldId id="276"/>
           </p14:sldIdLst>
         </p14:section>
       </p14:sectionLst>
@@ -207,6 +205,13 @@
             <a:schemeClr val="lt1"/>
           </a:fontRef>
         </p:style>
+        <p:txBody>
+          <a:bodyPr/>
+          <a:lstStyle/>
+          <a:p>
+            <a:endParaRPr lang="en-GB"/>
+          </a:p>
+        </p:txBody>
       </p:sp>
       <p:sp>
         <p:nvSpPr>
@@ -349,7 +354,7 @@
           <a:p>
             <a:fld id="{7E3A1397-DDBE-4990-A86F-207B0B9A1F2C}" type="datetimeFigureOut">
               <a:rPr lang="en-GB" smtClean="0"/>
-              <a:t>19/04/2023</a:t>
+              <a:t>06/11/2025</a:t>
             </a:fld>
             <a:endParaRPr lang="en-GB"/>
           </a:p>
@@ -450,6 +455,13 @@
             <a:schemeClr val="lt1"/>
           </a:fontRef>
         </p:style>
+        <p:txBody>
+          <a:bodyPr/>
+          <a:lstStyle/>
+          <a:p>
+            <a:endParaRPr lang="en-GB"/>
+          </a:p>
+        </p:txBody>
       </p:sp>
     </p:spTree>
     <p:extLst>
@@ -573,7 +585,7 @@
           <a:p>
             <a:fld id="{7E3A1397-DDBE-4990-A86F-207B0B9A1F2C}" type="datetimeFigureOut">
               <a:rPr lang="en-GB" smtClean="0"/>
-              <a:t>19/04/2023</a:t>
+              <a:t>06/11/2025</a:t>
             </a:fld>
             <a:endParaRPr lang="en-GB"/>
           </a:p>
@@ -753,7 +765,7 @@
           <a:p>
             <a:fld id="{7E3A1397-DDBE-4990-A86F-207B0B9A1F2C}" type="datetimeFigureOut">
               <a:rPr lang="en-GB" smtClean="0"/>
-              <a:t>19/04/2023</a:t>
+              <a:t>06/11/2025</a:t>
             </a:fld>
             <a:endParaRPr lang="en-GB"/>
           </a:p>
@@ -923,7 +935,7 @@
           <a:p>
             <a:fld id="{7E3A1397-DDBE-4990-A86F-207B0B9A1F2C}" type="datetimeFigureOut">
               <a:rPr lang="en-GB" smtClean="0"/>
-              <a:t>19/04/2023</a:t>
+              <a:t>06/11/2025</a:t>
             </a:fld>
             <a:endParaRPr lang="en-GB"/>
           </a:p>
@@ -1214,7 +1226,7 @@
           <a:p>
             <a:fld id="{7E3A1397-DDBE-4990-A86F-207B0B9A1F2C}" type="datetimeFigureOut">
               <a:rPr lang="en-GB" smtClean="0"/>
-              <a:t>19/04/2023</a:t>
+              <a:t>06/11/2025</a:t>
             </a:fld>
             <a:endParaRPr lang="en-GB"/>
           </a:p>
@@ -1540,7 +1552,7 @@
           <a:p>
             <a:fld id="{7E3A1397-DDBE-4990-A86F-207B0B9A1F2C}" type="datetimeFigureOut">
               <a:rPr lang="en-GB" smtClean="0"/>
-              <a:t>19/04/2023</a:t>
+              <a:t>06/11/2025</a:t>
             </a:fld>
             <a:endParaRPr lang="en-GB"/>
           </a:p>
@@ -1952,7 +1964,7 @@
           <a:p>
             <a:fld id="{7E3A1397-DDBE-4990-A86F-207B0B9A1F2C}" type="datetimeFigureOut">
               <a:rPr lang="en-GB" smtClean="0"/>
-              <a:t>19/04/2023</a:t>
+              <a:t>06/11/2025</a:t>
             </a:fld>
             <a:endParaRPr lang="en-GB"/>
           </a:p>
@@ -2070,7 +2082,7 @@
           <a:p>
             <a:fld id="{7E3A1397-DDBE-4990-A86F-207B0B9A1F2C}" type="datetimeFigureOut">
               <a:rPr lang="en-GB" smtClean="0"/>
-              <a:t>19/04/2023</a:t>
+              <a:t>06/11/2025</a:t>
             </a:fld>
             <a:endParaRPr lang="en-GB"/>
           </a:p>
@@ -2165,7 +2177,7 @@
           <a:p>
             <a:fld id="{7E3A1397-DDBE-4990-A86F-207B0B9A1F2C}" type="datetimeFigureOut">
               <a:rPr lang="en-GB" smtClean="0"/>
-              <a:t>19/04/2023</a:t>
+              <a:t>06/11/2025</a:t>
             </a:fld>
             <a:endParaRPr lang="en-GB"/>
           </a:p>
@@ -2452,7 +2464,7 @@
           <a:p>
             <a:fld id="{7E3A1397-DDBE-4990-A86F-207B0B9A1F2C}" type="datetimeFigureOut">
               <a:rPr lang="en-GB" smtClean="0"/>
-              <a:t>19/04/2023</a:t>
+              <a:t>06/11/2025</a:t>
             </a:fld>
             <a:endParaRPr lang="en-GB"/>
           </a:p>
@@ -2729,7 +2741,7 @@
           <a:p>
             <a:fld id="{7E3A1397-DDBE-4990-A86F-207B0B9A1F2C}" type="datetimeFigureOut">
               <a:rPr lang="en-GB" smtClean="0"/>
-              <a:t>19/04/2023</a:t>
+              <a:t>06/11/2025</a:t>
             </a:fld>
             <a:endParaRPr lang="en-GB"/>
           </a:p>
@@ -2849,6 +2861,13 @@
             <a:schemeClr val="lt1"/>
           </a:fontRef>
         </p:style>
+        <p:txBody>
+          <a:bodyPr/>
+          <a:lstStyle/>
+          <a:p>
+            <a:endParaRPr lang="en-GB"/>
+          </a:p>
+        </p:txBody>
       </p:sp>
       <p:sp>
         <p:nvSpPr>
@@ -2980,7 +2999,7 @@
           <a:p>
             <a:fld id="{7E3A1397-DDBE-4990-A86F-207B0B9A1F2C}" type="datetimeFigureOut">
               <a:rPr lang="en-GB" smtClean="0"/>
-              <a:t>19/04/2023</a:t>
+              <a:t>06/11/2025</a:t>
             </a:fld>
             <a:endParaRPr lang="en-GB"/>
           </a:p>
@@ -3481,20 +3500,13 @@
         <p:spPr/>
         <p:txBody>
           <a:bodyPr>
-            <a:normAutofit fontScale="90000"/>
+            <a:normAutofit/>
           </a:bodyPr>
           <a:lstStyle/>
           <a:p>
             <a:r>
               <a:rPr lang="en-GB" dirty="0"/>
-              <a:t>Statistics Development Workshop</a:t>
-            </a:r>
-            <a:br>
-              <a:rPr lang="en-GB" dirty="0"/>
-            </a:br>
-            <a:r>
-              <a:rPr lang="en-GB" dirty="0"/>
-              <a:t>Introduction to coding in R for RAP processes</a:t>
+              <a:t>Introduction to R for Reproducible Analytical Pipelines</a:t>
             </a:r>
           </a:p>
         </p:txBody>
@@ -3520,7 +3532,10 @@
           <a:bodyPr/>
           <a:lstStyle/>
           <a:p>
-            <a:endParaRPr lang="en-GB" dirty="0"/>
+            <a:r>
+              <a:rPr lang="en-GB" dirty="0"/>
+              <a:t>Statistics Services Unit</a:t>
+            </a:r>
           </a:p>
         </p:txBody>
       </p:sp>
@@ -3554,123 +3569,148 @@
           <a:chExt cx="0" cy="0"/>
         </a:xfrm>
       </p:grpSpPr>
-      <p:sp>
-        <p:nvSpPr>
-          <p:cNvPr id="2" name="Title 1">
+      <p:pic>
+        <p:nvPicPr>
+          <p:cNvPr id="1026" name="Picture 2">
             <a:extLst>
               <a:ext uri="{FF2B5EF4-FFF2-40B4-BE49-F238E27FC236}">
-                <a16:creationId xmlns:a16="http://schemas.microsoft.com/office/drawing/2014/main" id="{D047F8EF-BECC-CB05-2042-8E1A2F6D1C1A}"/>
+                <a16:creationId xmlns:a16="http://schemas.microsoft.com/office/drawing/2014/main" id="{1F58B4BF-6286-D367-F8C0-6BBF6985DAFE}"/>
               </a:ext>
             </a:extLst>
           </p:cNvPr>
-          <p:cNvSpPr>
-            <a:spLocks noGrp="1"/>
-          </p:cNvSpPr>
-          <p:nvPr>
-            <p:ph type="title"/>
-          </p:nvPr>
-        </p:nvSpPr>
-        <p:spPr/>
-        <p:txBody>
-          <a:bodyPr/>
-          <a:lstStyle/>
-          <a:p>
-            <a:r>
-              <a:rPr lang="en-GB" dirty="0"/>
-              <a:t>Getting set up</a:t>
-            </a:r>
-          </a:p>
-        </p:txBody>
-      </p:sp>
-      <p:sp>
-        <p:nvSpPr>
-          <p:cNvPr id="3" name="Content Placeholder 2">
+          <p:cNvPicPr>
+            <a:picLocks noGrp="1" noChangeAspect="1" noChangeArrowheads="1"/>
+          </p:cNvPicPr>
+          <p:nvPr>
+            <p:ph idx="1"/>
+          </p:nvPr>
+        </p:nvPicPr>
+        <p:blipFill>
+          <a:blip r:embed="rId2">
+            <a:extLst>
+              <a:ext uri="{28A0092B-C50C-407E-A947-70E740481C1C}">
+                <a14:useLocalDpi xmlns:a14="http://schemas.microsoft.com/office/drawing/2010/main" val="0"/>
+              </a:ext>
+            </a:extLst>
+          </a:blip>
+          <a:srcRect/>
+          <a:stretch>
+            <a:fillRect/>
+          </a:stretch>
+        </p:blipFill>
+        <p:spPr bwMode="auto">
+          <a:xfrm>
+            <a:off x="1798637" y="97808"/>
+            <a:ext cx="8594725" cy="3331192"/>
+          </a:xfrm>
+          <a:prstGeom prst="rect">
+            <a:avLst/>
+          </a:prstGeom>
+          <a:noFill/>
+          <a:extLst>
+            <a:ext uri="{909E8E84-426E-40DD-AFC4-6F175D3DCCD1}">
+              <a14:hiddenFill xmlns:a14="http://schemas.microsoft.com/office/drawing/2010/main">
+                <a:solidFill>
+                  <a:srgbClr val="FFFFFF"/>
+                </a:solidFill>
+              </a14:hiddenFill>
+            </a:ext>
+          </a:extLst>
+        </p:spPr>
+      </p:pic>
+      <p:pic>
+        <p:nvPicPr>
+          <p:cNvPr id="1028" name="Picture 4">
             <a:extLst>
               <a:ext uri="{FF2B5EF4-FFF2-40B4-BE49-F238E27FC236}">
-                <a16:creationId xmlns:a16="http://schemas.microsoft.com/office/drawing/2014/main" id="{476F0551-B6E7-9358-79EA-9B20DDC8DAF3}"/>
+                <a16:creationId xmlns:a16="http://schemas.microsoft.com/office/drawing/2014/main" id="{E87C30D8-DFD5-36C0-25BD-581F08C05B3F}"/>
               </a:ext>
             </a:extLst>
           </p:cNvPr>
-          <p:cNvSpPr>
-            <a:spLocks noGrp="1"/>
-          </p:cNvSpPr>
-          <p:nvPr>
-            <p:ph idx="1"/>
-          </p:nvPr>
-        </p:nvSpPr>
-        <p:spPr/>
-        <p:txBody>
-          <a:bodyPr>
-            <a:normAutofit/>
-          </a:bodyPr>
-          <a:lstStyle/>
-          <a:p>
-            <a:r>
-              <a:rPr lang="en-GB" dirty="0"/>
-              <a:t>This is a </a:t>
-            </a:r>
-            <a:r>
-              <a:rPr lang="en-GB" b="1" i="1" dirty="0"/>
-              <a:t>live coding</a:t>
-            </a:r>
-            <a:r>
-              <a:rPr lang="en-GB" dirty="0"/>
-              <a:t> session, so we need you set up with git and RStudio installed…</a:t>
-            </a:r>
-          </a:p>
-          <a:p>
-            <a:r>
-              <a:rPr lang="en-GB" dirty="0"/>
-              <a:t>Open up the pdf that we’ve shared for this session or go to the following link:</a:t>
-            </a:r>
-          </a:p>
-          <a:p>
-            <a:pPr lvl="1"/>
-            <a:r>
-              <a:rPr lang="en-GB" dirty="0"/>
-              <a:t>Add the link Charlotte!</a:t>
-            </a:r>
-          </a:p>
-          <a:p>
-            <a:r>
-              <a:rPr lang="en-GB" dirty="0"/>
-              <a:t>Go to pre-workshop requirements section and check you’ve got everything from that list sorted (copied below). Get help from us if anything didn’t work!</a:t>
-            </a:r>
-          </a:p>
-          <a:p>
-            <a:pPr lvl="1"/>
-            <a:r>
-              <a:rPr lang="en-GB" dirty="0"/>
-              <a:t>Create a DfE Dev Ops account via the Service Portal;</a:t>
-            </a:r>
-          </a:p>
-          <a:p>
-            <a:pPr lvl="1"/>
-            <a:r>
-              <a:rPr lang="en-GB" dirty="0"/>
-              <a:t>Install git on your laptop: https://git-scm.com/downloads;</a:t>
-            </a:r>
-          </a:p>
-          <a:p>
-            <a:pPr lvl="1"/>
-            <a:r>
-              <a:rPr lang="en-GB" dirty="0"/>
-              <a:t>Install R-Studio on your machine: Download R for Windows (x64) and RStudio from the Software Centre on your DfE laptop.</a:t>
-            </a:r>
-          </a:p>
-          <a:p>
-            <a:pPr lvl="1"/>
-            <a:r>
-              <a:rPr lang="en-GB" dirty="0"/>
-              <a:t>Set up the path to the git.exe in RStudio global settings.</a:t>
-            </a:r>
-          </a:p>
-        </p:txBody>
-      </p:sp>
+          <p:cNvPicPr>
+            <a:picLocks noChangeAspect="1" noChangeArrowheads="1"/>
+          </p:cNvPicPr>
+          <p:nvPr/>
+        </p:nvPicPr>
+        <p:blipFill>
+          <a:blip r:embed="rId3">
+            <a:extLst>
+              <a:ext uri="{28A0092B-C50C-407E-A947-70E740481C1C}">
+                <a14:useLocalDpi xmlns:a14="http://schemas.microsoft.com/office/drawing/2010/main" val="0"/>
+              </a:ext>
+            </a:extLst>
+          </a:blip>
+          <a:srcRect/>
+          <a:stretch>
+            <a:fillRect/>
+          </a:stretch>
+        </p:blipFill>
+        <p:spPr bwMode="auto">
+          <a:xfrm>
+            <a:off x="618743" y="4848120"/>
+            <a:ext cx="10954512" cy="1683115"/>
+          </a:xfrm>
+          <a:prstGeom prst="rect">
+            <a:avLst/>
+          </a:prstGeom>
+          <a:noFill/>
+          <a:extLst>
+            <a:ext uri="{909E8E84-426E-40DD-AFC4-6F175D3DCCD1}">
+              <a14:hiddenFill xmlns:a14="http://schemas.microsoft.com/office/drawing/2010/main">
+                <a:solidFill>
+                  <a:srgbClr val="FFFFFF"/>
+                </a:solidFill>
+              </a14:hiddenFill>
+            </a:ext>
+          </a:extLst>
+        </p:spPr>
+      </p:pic>
+      <p:cxnSp>
+        <p:nvCxnSpPr>
+          <p:cNvPr id="5" name="Straight Arrow Connector 4">
+            <a:extLst>
+              <a:ext uri="{FF2B5EF4-FFF2-40B4-BE49-F238E27FC236}">
+                <a16:creationId xmlns:a16="http://schemas.microsoft.com/office/drawing/2014/main" id="{1E32565E-5CB9-A305-C4C9-7AA771471C03}"/>
+              </a:ext>
+            </a:extLst>
+          </p:cNvPr>
+          <p:cNvCxnSpPr/>
+          <p:nvPr/>
+        </p:nvCxnSpPr>
+        <p:spPr>
+          <a:xfrm>
+            <a:off x="6108192" y="3614468"/>
+            <a:ext cx="0" cy="1052423"/>
+          </a:xfrm>
+          <a:prstGeom prst="straightConnector1">
+            <a:avLst/>
+          </a:prstGeom>
+          <a:ln w="76200">
+            <a:solidFill>
+              <a:schemeClr val="tx1"/>
+            </a:solidFill>
+            <a:tailEnd type="triangle"/>
+          </a:ln>
+        </p:spPr>
+        <p:style>
+          <a:lnRef idx="1">
+            <a:schemeClr val="accent1"/>
+          </a:lnRef>
+          <a:fillRef idx="0">
+            <a:schemeClr val="accent1"/>
+          </a:fillRef>
+          <a:effectRef idx="0">
+            <a:schemeClr val="accent1"/>
+          </a:effectRef>
+          <a:fontRef idx="minor">
+            <a:schemeClr val="tx1"/>
+          </a:fontRef>
+        </p:style>
+      </p:cxnSp>
     </p:spTree>
     <p:extLst>
       <p:ext uri="{BB962C8B-B14F-4D97-AF65-F5344CB8AC3E}">
-        <p14:creationId xmlns:p14="http://schemas.microsoft.com/office/powerpoint/2010/main" val="916788589"/>
+        <p14:creationId xmlns:p14="http://schemas.microsoft.com/office/powerpoint/2010/main" val="2713344255"/>
       </p:ext>
     </p:extLst>
   </p:cSld>
@@ -3702,7 +3742,7 @@
           <p:cNvPr id="2" name="Title 1">
             <a:extLst>
               <a:ext uri="{FF2B5EF4-FFF2-40B4-BE49-F238E27FC236}">
-                <a16:creationId xmlns:a16="http://schemas.microsoft.com/office/drawing/2014/main" id="{4FF0CB11-79F6-AF60-4DAA-A7DC4C163D93}"/>
+                <a16:creationId xmlns:a16="http://schemas.microsoft.com/office/drawing/2014/main" id="{D047F8EF-BECC-CB05-2042-8E1A2F6D1C1A}"/>
               </a:ext>
             </a:extLst>
           </p:cNvPr>
@@ -3720,7 +3760,7 @@
           <a:p>
             <a:r>
               <a:rPr lang="en-GB" dirty="0"/>
-              <a:t>Lets get started!</a:t>
+              <a:t>Getting set up</a:t>
             </a:r>
           </a:p>
         </p:txBody>
@@ -3730,7 +3770,7 @@
           <p:cNvPr id="3" name="Content Placeholder 2">
             <a:extLst>
               <a:ext uri="{FF2B5EF4-FFF2-40B4-BE49-F238E27FC236}">
-                <a16:creationId xmlns:a16="http://schemas.microsoft.com/office/drawing/2014/main" id="{74DA94FC-A6F4-0A14-94BE-1263ECFF3856}"/>
+                <a16:creationId xmlns:a16="http://schemas.microsoft.com/office/drawing/2014/main" id="{476F0551-B6E7-9358-79EA-9B20DDC8DAF3}"/>
               </a:ext>
             </a:extLst>
           </p:cNvPr>
@@ -3743,24 +3783,51 @@
         </p:nvSpPr>
         <p:spPr/>
         <p:txBody>
-          <a:bodyPr/>
+          <a:bodyPr>
+            <a:normAutofit/>
+          </a:bodyPr>
           <a:lstStyle/>
           <a:p>
             <a:r>
               <a:rPr lang="en-GB" dirty="0"/>
-              <a:t>Everyone, open the R project.</a:t>
-            </a:r>
-          </a:p>
-          <a:p>
+              <a:t>This is a </a:t>
+            </a:r>
+            <a:r>
+              <a:rPr lang="en-GB" b="1" i="1" dirty="0"/>
+              <a:t>live coding</a:t>
+            </a:r>
             <a:r>
               <a:rPr lang="en-GB" dirty="0"/>
-              <a:t>Navigate to your team’s branch. </a:t>
+              <a:t> session, so you’ll need to have R &amp; RStudio installed</a:t>
             </a:r>
           </a:p>
           <a:p>
             <a:r>
               <a:rPr lang="en-GB" dirty="0"/>
-              <a:t>Begin working through the tasks.</a:t>
+              <a:t>Open the workshop PDF file: </a:t>
+            </a:r>
+            <a:r>
+              <a:rPr lang="en-GB" dirty="0">
+                <a:hlinkClick r:id="rId2"/>
+              </a:rPr>
+              <a:t>https://github.com/dfe-analytical-services/techskills_workshops/blob/main/workshop_R.pdf</a:t>
+            </a:r>
+            <a:r>
+              <a:rPr lang="en-GB" dirty="0"/>
+              <a:t> </a:t>
+            </a:r>
+          </a:p>
+          <a:p>
+            <a:r>
+              <a:rPr lang="en-GB" dirty="0"/>
+              <a:t>Check you’ve got everything in the pre-workshop requirements. Get help from us if anything didn’t work!</a:t>
+            </a:r>
+          </a:p>
+          <a:p>
+            <a:pPr lvl="1"/>
+            <a:r>
+              <a:rPr lang="en-GB" dirty="0"/>
+              <a:t>Download R for Windows (x64) and RStudio from the Software Centre on your DfE laptop.</a:t>
             </a:r>
           </a:p>
         </p:txBody>
@@ -3768,7 +3835,616 @@
     </p:spTree>
     <p:extLst>
       <p:ext uri="{BB962C8B-B14F-4D97-AF65-F5344CB8AC3E}">
-        <p14:creationId xmlns:p14="http://schemas.microsoft.com/office/powerpoint/2010/main" val="1988881035"/>
+        <p14:creationId xmlns:p14="http://schemas.microsoft.com/office/powerpoint/2010/main" val="916788589"/>
+      </p:ext>
+    </p:extLst>
+  </p:cSld>
+  <p:clrMapOvr>
+    <a:masterClrMapping/>
+  </p:clrMapOvr>
+</p:sld>
+</file>
+
+<file path=ppt/slides/slide12.xml><?xml version="1.0" encoding="utf-8"?>
+<p:sld xmlns:a="http://schemas.openxmlformats.org/drawingml/2006/main" xmlns:r="http://schemas.openxmlformats.org/officeDocument/2006/relationships" xmlns:p="http://schemas.openxmlformats.org/presentationml/2006/main">
+  <p:cSld>
+    <p:spTree>
+      <p:nvGrpSpPr>
+        <p:cNvPr id="1" name=""/>
+        <p:cNvGrpSpPr/>
+        <p:nvPr/>
+      </p:nvGrpSpPr>
+      <p:grpSpPr>
+        <a:xfrm>
+          <a:off x="0" y="0"/>
+          <a:ext cx="0" cy="0"/>
+          <a:chOff x="0" y="0"/>
+          <a:chExt cx="0" cy="0"/>
+        </a:xfrm>
+      </p:grpSpPr>
+      <p:sp>
+        <p:nvSpPr>
+          <p:cNvPr id="2" name="Title 1">
+            <a:extLst>
+              <a:ext uri="{FF2B5EF4-FFF2-40B4-BE49-F238E27FC236}">
+                <a16:creationId xmlns:a16="http://schemas.microsoft.com/office/drawing/2014/main" id="{88D5E3D0-6F78-C65E-3F15-F318DE8EA252}"/>
+              </a:ext>
+            </a:extLst>
+          </p:cNvPr>
+          <p:cNvSpPr>
+            <a:spLocks noGrp="1"/>
+          </p:cNvSpPr>
+          <p:nvPr>
+            <p:ph type="title"/>
+          </p:nvPr>
+        </p:nvSpPr>
+        <p:spPr>
+          <a:xfrm>
+            <a:off x="948890" y="365760"/>
+            <a:ext cx="9692640" cy="738884"/>
+          </a:xfrm>
+        </p:spPr>
+        <p:txBody>
+          <a:bodyPr/>
+          <a:lstStyle/>
+          <a:p>
+            <a:r>
+              <a:rPr lang="en-GB" dirty="0"/>
+              <a:t>Workshop topics</a:t>
+            </a:r>
+          </a:p>
+        </p:txBody>
+      </p:sp>
+      <p:sp>
+        <p:nvSpPr>
+          <p:cNvPr id="3" name="Content Placeholder 2">
+            <a:extLst>
+              <a:ext uri="{FF2B5EF4-FFF2-40B4-BE49-F238E27FC236}">
+                <a16:creationId xmlns:a16="http://schemas.microsoft.com/office/drawing/2014/main" id="{E683C1DA-456E-6C9E-E7EC-0776C4AB6FF6}"/>
+              </a:ext>
+            </a:extLst>
+          </p:cNvPr>
+          <p:cNvSpPr>
+            <a:spLocks noGrp="1"/>
+          </p:cNvSpPr>
+          <p:nvPr>
+            <p:ph idx="1"/>
+          </p:nvPr>
+        </p:nvSpPr>
+        <p:spPr>
+          <a:xfrm>
+            <a:off x="384852" y="1348790"/>
+            <a:ext cx="5705395" cy="5055079"/>
+          </a:xfrm>
+        </p:spPr>
+        <p:txBody>
+          <a:bodyPr>
+            <a:normAutofit fontScale="25000" lnSpcReduction="20000"/>
+          </a:bodyPr>
+          <a:lstStyle/>
+          <a:p>
+            <a:r>
+              <a:rPr lang="en-GB" sz="6400" dirty="0"/>
+              <a:t>Introduction &amp; pre-workshop requirements</a:t>
+            </a:r>
+          </a:p>
+          <a:p>
+            <a:r>
+              <a:rPr lang="en-GB" sz="6400" dirty="0"/>
+              <a:t>Creating a project </a:t>
+            </a:r>
+          </a:p>
+          <a:p>
+            <a:r>
+              <a:rPr lang="en-GB" sz="6400" dirty="0"/>
+              <a:t>Using </a:t>
+            </a:r>
+            <a:r>
+              <a:rPr lang="en-GB" sz="6400" dirty="0" err="1"/>
+              <a:t>renv</a:t>
+            </a:r>
+            <a:r>
+              <a:rPr lang="en-GB" sz="6400" dirty="0"/>
+              <a:t> (optional) </a:t>
+            </a:r>
+          </a:p>
+          <a:p>
+            <a:r>
+              <a:rPr lang="en-GB" sz="6400" dirty="0"/>
+              <a:t>Your initial script</a:t>
+            </a:r>
+          </a:p>
+          <a:p>
+            <a:pPr lvl="1"/>
+            <a:r>
+              <a:rPr lang="en-GB" sz="6400" dirty="0">
+                <a:solidFill>
+                  <a:schemeClr val="tx1"/>
+                </a:solidFill>
+              </a:rPr>
+              <a:t>Comments and headings</a:t>
+            </a:r>
+          </a:p>
+          <a:p>
+            <a:pPr lvl="1"/>
+            <a:r>
+              <a:rPr lang="en-GB" sz="6400" dirty="0">
+                <a:solidFill>
+                  <a:schemeClr val="tx1"/>
+                </a:solidFill>
+              </a:rPr>
+              <a:t>Adding and running code</a:t>
+            </a:r>
+          </a:p>
+          <a:p>
+            <a:pPr lvl="1"/>
+            <a:r>
+              <a:rPr lang="en-GB" sz="6400" dirty="0">
+                <a:solidFill>
+                  <a:schemeClr val="tx1"/>
+                </a:solidFill>
+              </a:rPr>
+              <a:t>Data types and objects</a:t>
+            </a:r>
+          </a:p>
+          <a:p>
+            <a:pPr lvl="1"/>
+            <a:r>
+              <a:rPr lang="en-GB" sz="6400" dirty="0">
+                <a:solidFill>
+                  <a:schemeClr val="tx1"/>
+                </a:solidFill>
+              </a:rPr>
+              <a:t>Loading in the data</a:t>
+            </a:r>
+          </a:p>
+          <a:p>
+            <a:r>
+              <a:rPr lang="en-GB" sz="6400" dirty="0"/>
+              <a:t>Cleaning data</a:t>
+            </a:r>
+          </a:p>
+          <a:p>
+            <a:pPr lvl="1"/>
+            <a:r>
+              <a:rPr lang="en-GB" sz="6400" dirty="0"/>
+              <a:t>Missing values</a:t>
+            </a:r>
+          </a:p>
+          <a:p>
+            <a:pPr lvl="1"/>
+            <a:r>
+              <a:rPr lang="en-GB" sz="6400" dirty="0"/>
+              <a:t>Duplicates</a:t>
+            </a:r>
+          </a:p>
+          <a:p>
+            <a:r>
+              <a:rPr lang="en-GB" sz="6400" dirty="0"/>
+              <a:t>Descriptive statistics</a:t>
+            </a:r>
+          </a:p>
+          <a:p>
+            <a:r>
+              <a:rPr lang="en-GB" sz="6400" dirty="0"/>
+              <a:t>Manipulating data</a:t>
+            </a:r>
+          </a:p>
+          <a:p>
+            <a:pPr lvl="1"/>
+            <a:r>
+              <a:rPr lang="en-GB" sz="6400" dirty="0"/>
+              <a:t>Aggregating</a:t>
+            </a:r>
+          </a:p>
+          <a:p>
+            <a:pPr lvl="1"/>
+            <a:r>
+              <a:rPr lang="en-GB" sz="6400" dirty="0"/>
+              <a:t>Filtering</a:t>
+            </a:r>
+          </a:p>
+          <a:p>
+            <a:pPr lvl="1"/>
+            <a:r>
+              <a:rPr lang="en-GB" sz="6400" dirty="0"/>
+              <a:t>Reordering &amp; renaming</a:t>
+            </a:r>
+          </a:p>
+          <a:p>
+            <a:r>
+              <a:rPr lang="en-GB" sz="6800" dirty="0"/>
+              <a:t>Writing functions &amp; if / </a:t>
+            </a:r>
+            <a:r>
+              <a:rPr lang="en-GB" sz="6800" dirty="0" err="1"/>
+              <a:t>ifelse</a:t>
+            </a:r>
+            <a:r>
+              <a:rPr lang="en-GB" sz="6800" dirty="0"/>
+              <a:t> statements</a:t>
+            </a:r>
+          </a:p>
+          <a:p>
+            <a:pPr lvl="1"/>
+            <a:endParaRPr lang="en-GB" sz="6400" dirty="0"/>
+          </a:p>
+          <a:p>
+            <a:pPr lvl="1"/>
+            <a:endParaRPr lang="en-GB" sz="6400" dirty="0"/>
+          </a:p>
+          <a:p>
+            <a:endParaRPr lang="en-GB" sz="2000" dirty="0"/>
+          </a:p>
+        </p:txBody>
+      </p:sp>
+      <p:sp>
+        <p:nvSpPr>
+          <p:cNvPr id="4" name="Content Placeholder 2">
+            <a:extLst>
+              <a:ext uri="{FF2B5EF4-FFF2-40B4-BE49-F238E27FC236}">
+                <a16:creationId xmlns:a16="http://schemas.microsoft.com/office/drawing/2014/main" id="{D7327EB2-4E62-A191-17D8-59A03534EAF0}"/>
+              </a:ext>
+            </a:extLst>
+          </p:cNvPr>
+          <p:cNvSpPr txBox="1">
+            <a:spLocks/>
+          </p:cNvSpPr>
+          <p:nvPr/>
+        </p:nvSpPr>
+        <p:spPr>
+          <a:xfrm>
+            <a:off x="6101753" y="1705771"/>
+            <a:ext cx="5705395" cy="4698098"/>
+          </a:xfrm>
+          <a:prstGeom prst="rect">
+            <a:avLst/>
+          </a:prstGeom>
+        </p:spPr>
+        <p:txBody>
+          <a:bodyPr vert="horz" lIns="91440" tIns="45720" rIns="91440" bIns="45720" rtlCol="0">
+            <a:noAutofit/>
+          </a:bodyPr>
+          <a:lstStyle>
+            <a:lvl1pPr marL="182880" indent="-182880" algn="l" defTabSz="914400" rtl="0" eaLnBrk="1" latinLnBrk="0" hangingPunct="1">
+              <a:lnSpc>
+                <a:spcPct val="95000"/>
+              </a:lnSpc>
+              <a:spcBef>
+                <a:spcPts val="1400"/>
+              </a:spcBef>
+              <a:spcAft>
+                <a:spcPts val="200"/>
+              </a:spcAft>
+              <a:buClr>
+                <a:schemeClr val="accent1"/>
+              </a:buClr>
+              <a:buSzPct val="80000"/>
+              <a:buFont typeface="Arial" pitchFamily="34" charset="0"/>
+              <a:buChar char="•"/>
+              <a:defRPr sz="1800" kern="1200" spc="10" baseline="0">
+                <a:solidFill>
+                  <a:schemeClr val="tx1"/>
+                </a:solidFill>
+                <a:latin typeface="+mn-lt"/>
+                <a:ea typeface="+mn-ea"/>
+                <a:cs typeface="+mn-cs"/>
+              </a:defRPr>
+            </a:lvl1pPr>
+            <a:lvl2pPr marL="457200" indent="-182880" algn="l" defTabSz="914400" rtl="0" eaLnBrk="1" latinLnBrk="0" hangingPunct="1">
+              <a:lnSpc>
+                <a:spcPct val="90000"/>
+              </a:lnSpc>
+              <a:spcBef>
+                <a:spcPts val="300"/>
+              </a:spcBef>
+              <a:spcAft>
+                <a:spcPts val="300"/>
+              </a:spcAft>
+              <a:buClr>
+                <a:schemeClr val="accent1"/>
+              </a:buClr>
+              <a:buFont typeface="Wingdings 2" pitchFamily="18" charset="2"/>
+              <a:buChar char=""/>
+              <a:defRPr sz="1600" kern="1200">
+                <a:solidFill>
+                  <a:schemeClr val="tx1">
+                    <a:lumMod val="85000"/>
+                    <a:lumOff val="15000"/>
+                  </a:schemeClr>
+                </a:solidFill>
+                <a:latin typeface="+mn-lt"/>
+                <a:ea typeface="+mn-ea"/>
+                <a:cs typeface="+mn-cs"/>
+              </a:defRPr>
+            </a:lvl2pPr>
+            <a:lvl3pPr marL="731520" indent="-182880" algn="l" defTabSz="914400" rtl="0" eaLnBrk="1" latinLnBrk="0" hangingPunct="1">
+              <a:lnSpc>
+                <a:spcPct val="90000"/>
+              </a:lnSpc>
+              <a:spcBef>
+                <a:spcPts val="300"/>
+              </a:spcBef>
+              <a:spcAft>
+                <a:spcPts val="300"/>
+              </a:spcAft>
+              <a:buClr>
+                <a:schemeClr val="accent1"/>
+              </a:buClr>
+              <a:buFont typeface="Wingdings 2" pitchFamily="18" charset="2"/>
+              <a:buChar char=""/>
+              <a:defRPr sz="1400" kern="1200">
+                <a:solidFill>
+                  <a:schemeClr val="tx1">
+                    <a:lumMod val="85000"/>
+                    <a:lumOff val="15000"/>
+                  </a:schemeClr>
+                </a:solidFill>
+                <a:latin typeface="+mn-lt"/>
+                <a:ea typeface="+mn-ea"/>
+                <a:cs typeface="+mn-cs"/>
+              </a:defRPr>
+            </a:lvl3pPr>
+            <a:lvl4pPr marL="1005840" indent="-182880" algn="l" defTabSz="914400" rtl="0" eaLnBrk="1" latinLnBrk="0" hangingPunct="1">
+              <a:lnSpc>
+                <a:spcPct val="90000"/>
+              </a:lnSpc>
+              <a:spcBef>
+                <a:spcPts val="300"/>
+              </a:spcBef>
+              <a:spcAft>
+                <a:spcPts val="300"/>
+              </a:spcAft>
+              <a:buClr>
+                <a:schemeClr val="accent1"/>
+              </a:buClr>
+              <a:buFont typeface="Wingdings 2" pitchFamily="18" charset="2"/>
+              <a:buChar char=""/>
+              <a:defRPr sz="1400" kern="1200">
+                <a:solidFill>
+                  <a:schemeClr val="tx1">
+                    <a:lumMod val="85000"/>
+                    <a:lumOff val="15000"/>
+                  </a:schemeClr>
+                </a:solidFill>
+                <a:latin typeface="+mn-lt"/>
+                <a:ea typeface="+mn-ea"/>
+                <a:cs typeface="+mn-cs"/>
+              </a:defRPr>
+            </a:lvl4pPr>
+            <a:lvl5pPr marL="1280160" indent="-182880" algn="l" defTabSz="914400" rtl="0" eaLnBrk="1" latinLnBrk="0" hangingPunct="1">
+              <a:lnSpc>
+                <a:spcPct val="90000"/>
+              </a:lnSpc>
+              <a:spcBef>
+                <a:spcPts val="300"/>
+              </a:spcBef>
+              <a:spcAft>
+                <a:spcPts val="300"/>
+              </a:spcAft>
+              <a:buClr>
+                <a:schemeClr val="accent1"/>
+              </a:buClr>
+              <a:buFont typeface="Wingdings 2" pitchFamily="18" charset="2"/>
+              <a:buChar char=""/>
+              <a:defRPr sz="1400" kern="1200">
+                <a:solidFill>
+                  <a:schemeClr val="tx1">
+                    <a:lumMod val="85000"/>
+                    <a:lumOff val="15000"/>
+                  </a:schemeClr>
+                </a:solidFill>
+                <a:latin typeface="+mn-lt"/>
+                <a:ea typeface="+mn-ea"/>
+                <a:cs typeface="+mn-cs"/>
+              </a:defRPr>
+            </a:lvl5pPr>
+            <a:lvl6pPr marL="1600000" indent="-228600" algn="l" defTabSz="914400" rtl="0" eaLnBrk="1" latinLnBrk="0" hangingPunct="1">
+              <a:lnSpc>
+                <a:spcPct val="90000"/>
+              </a:lnSpc>
+              <a:spcBef>
+                <a:spcPts val="300"/>
+              </a:spcBef>
+              <a:spcAft>
+                <a:spcPts val="300"/>
+              </a:spcAft>
+              <a:buClr>
+                <a:schemeClr val="accent1"/>
+              </a:buClr>
+              <a:buFont typeface="Wingdings 2" pitchFamily="18" charset="2"/>
+              <a:buChar char=""/>
+              <a:defRPr sz="1400" kern="1200">
+                <a:solidFill>
+                  <a:schemeClr val="tx1">
+                    <a:lumMod val="85000"/>
+                    <a:lumOff val="15000"/>
+                  </a:schemeClr>
+                </a:solidFill>
+                <a:latin typeface="+mn-lt"/>
+                <a:ea typeface="+mn-ea"/>
+                <a:cs typeface="+mn-cs"/>
+              </a:defRPr>
+            </a:lvl6pPr>
+            <a:lvl7pPr marL="1900000" indent="-228600" algn="l" defTabSz="914400" rtl="0" eaLnBrk="1" latinLnBrk="0" hangingPunct="1">
+              <a:lnSpc>
+                <a:spcPct val="90000"/>
+              </a:lnSpc>
+              <a:spcBef>
+                <a:spcPts val="300"/>
+              </a:spcBef>
+              <a:spcAft>
+                <a:spcPts val="300"/>
+              </a:spcAft>
+              <a:buClr>
+                <a:schemeClr val="accent1"/>
+              </a:buClr>
+              <a:buFont typeface="Wingdings 2" pitchFamily="18" charset="2"/>
+              <a:buChar char=""/>
+              <a:defRPr sz="1400" kern="1200">
+                <a:solidFill>
+                  <a:schemeClr val="tx1">
+                    <a:lumMod val="85000"/>
+                    <a:lumOff val="15000"/>
+                  </a:schemeClr>
+                </a:solidFill>
+                <a:latin typeface="+mn-lt"/>
+                <a:ea typeface="+mn-ea"/>
+                <a:cs typeface="+mn-cs"/>
+              </a:defRPr>
+            </a:lvl7pPr>
+            <a:lvl8pPr marL="2200000" indent="-228600" algn="l" defTabSz="914400" rtl="0" eaLnBrk="1" latinLnBrk="0" hangingPunct="1">
+              <a:lnSpc>
+                <a:spcPct val="90000"/>
+              </a:lnSpc>
+              <a:spcBef>
+                <a:spcPts val="300"/>
+              </a:spcBef>
+              <a:spcAft>
+                <a:spcPts val="300"/>
+              </a:spcAft>
+              <a:buClr>
+                <a:schemeClr val="accent1"/>
+              </a:buClr>
+              <a:buFont typeface="Wingdings 2" pitchFamily="18" charset="2"/>
+              <a:buChar char=""/>
+              <a:defRPr sz="1400" kern="1200">
+                <a:solidFill>
+                  <a:schemeClr val="tx1">
+                    <a:lumMod val="85000"/>
+                    <a:lumOff val="15000"/>
+                  </a:schemeClr>
+                </a:solidFill>
+                <a:latin typeface="+mn-lt"/>
+                <a:ea typeface="+mn-ea"/>
+                <a:cs typeface="+mn-cs"/>
+              </a:defRPr>
+            </a:lvl8pPr>
+            <a:lvl9pPr marL="2500000" indent="-228600" algn="l" defTabSz="914400" rtl="0" eaLnBrk="1" latinLnBrk="0" hangingPunct="1">
+              <a:lnSpc>
+                <a:spcPct val="90000"/>
+              </a:lnSpc>
+              <a:spcBef>
+                <a:spcPts val="300"/>
+              </a:spcBef>
+              <a:spcAft>
+                <a:spcPts val="300"/>
+              </a:spcAft>
+              <a:buClr>
+                <a:schemeClr val="accent1"/>
+              </a:buClr>
+              <a:buFont typeface="Wingdings 2" pitchFamily="18" charset="2"/>
+              <a:buChar char=""/>
+              <a:defRPr sz="1400" kern="1200">
+                <a:solidFill>
+                  <a:schemeClr val="tx1">
+                    <a:lumMod val="85000"/>
+                    <a:lumOff val="15000"/>
+                  </a:schemeClr>
+                </a:solidFill>
+                <a:latin typeface="+mn-lt"/>
+                <a:ea typeface="+mn-ea"/>
+                <a:cs typeface="+mn-cs"/>
+              </a:defRPr>
+            </a:lvl9pPr>
+          </a:lstStyle>
+          <a:p>
+            <a:r>
+              <a:rPr lang="en-GB" sz="1600" dirty="0"/>
+              <a:t>Joining data</a:t>
+            </a:r>
+          </a:p>
+          <a:p>
+            <a:r>
+              <a:rPr lang="en-GB" sz="1600" dirty="0"/>
+              <a:t>Creating plots</a:t>
+            </a:r>
+          </a:p>
+          <a:p>
+            <a:r>
+              <a:rPr lang="en-GB" sz="1600" dirty="0"/>
+              <a:t>Creating functions for plots</a:t>
+            </a:r>
+          </a:p>
+          <a:p>
+            <a:r>
+              <a:rPr lang="en-GB" sz="1600" dirty="0"/>
+              <a:t>Using online resources</a:t>
+            </a:r>
+          </a:p>
+          <a:p>
+            <a:pPr lvl="1"/>
+            <a:r>
+              <a:rPr lang="en-GB" dirty="0">
+                <a:solidFill>
+                  <a:schemeClr val="tx1"/>
+                </a:solidFill>
+              </a:rPr>
+              <a:t>Google questions and errors </a:t>
+            </a:r>
+          </a:p>
+          <a:p>
+            <a:pPr lvl="1"/>
+            <a:r>
+              <a:rPr lang="en-GB" dirty="0">
+                <a:solidFill>
+                  <a:schemeClr val="tx1"/>
+                </a:solidFill>
+              </a:rPr>
+              <a:t>Using Copilot</a:t>
+            </a:r>
+          </a:p>
+          <a:p>
+            <a:r>
+              <a:rPr lang="en-GB" sz="1600" dirty="0"/>
+              <a:t>w-RAP it up</a:t>
+            </a:r>
+          </a:p>
+          <a:p>
+            <a:r>
+              <a:rPr lang="en-GB" sz="1600" dirty="0"/>
+              <a:t>Unit testing in R</a:t>
+            </a:r>
+          </a:p>
+          <a:p>
+            <a:r>
+              <a:rPr lang="en-GB" sz="1600" dirty="0" err="1"/>
+              <a:t>dplyr</a:t>
+            </a:r>
+            <a:r>
+              <a:rPr lang="en-GB" sz="1600" dirty="0"/>
+              <a:t> vs. </a:t>
+            </a:r>
+            <a:r>
+              <a:rPr lang="en-GB" sz="1600" dirty="0" err="1"/>
+              <a:t>data.table</a:t>
+            </a:r>
+            <a:endParaRPr lang="en-GB" sz="1600" dirty="0"/>
+          </a:p>
+          <a:p>
+            <a:r>
+              <a:rPr lang="en-GB" sz="1600" dirty="0"/>
+              <a:t>Troubleshooting</a:t>
+            </a:r>
+          </a:p>
+          <a:p>
+            <a:r>
+              <a:rPr lang="en-GB" sz="1600" dirty="0"/>
+              <a:t>Excel functions in R</a:t>
+            </a:r>
+          </a:p>
+          <a:p>
+            <a:r>
+              <a:rPr lang="en-GB" sz="1600" dirty="0"/>
+              <a:t>Accessing remote data (optional)</a:t>
+            </a:r>
+          </a:p>
+        </p:txBody>
+      </p:sp>
+    </p:spTree>
+    <p:extLst>
+      <p:ext uri="{BB962C8B-B14F-4D97-AF65-F5344CB8AC3E}">
+        <p14:creationId xmlns:p14="http://schemas.microsoft.com/office/powerpoint/2010/main" val="2181686125"/>
       </p:ext>
     </p:extLst>
   </p:cSld>
@@ -3848,7 +4524,7 @@
           <a:p>
             <a:r>
               <a:rPr lang="en-GB" dirty="0"/>
-              <a:t>Understand the benefits of RAP</a:t>
+              <a:t>Understand the benefits of Reproducible Analytical Pipelines (RAP)</a:t>
             </a:r>
           </a:p>
           <a:p>
@@ -3862,73 +4538,69 @@
             <a:pPr lvl="1"/>
             <a:r>
               <a:rPr lang="en-GB" dirty="0"/>
-              <a:t>What is the point?</a:t>
+              <a:t>What is the point of RAP?</a:t>
             </a:r>
           </a:p>
           <a:p>
             <a:pPr lvl="1"/>
             <a:r>
               <a:rPr lang="en-GB" dirty="0"/>
-              <a:t>Why invest the time to change things?</a:t>
+              <a:t>Why invest time to apply RAP principles?</a:t>
             </a:r>
           </a:p>
           <a:p>
             <a:r>
               <a:rPr lang="en-GB" dirty="0"/>
-              <a:t>More confidence coding in R</a:t>
+              <a:t>Gain confidence with coding in R</a:t>
             </a:r>
           </a:p>
           <a:p>
             <a:pPr lvl="1"/>
             <a:r>
               <a:rPr lang="en-GB" dirty="0"/>
-              <a:t>Understanding format and syntax of R </a:t>
+              <a:t>Understand what R is, its format and syntax</a:t>
             </a:r>
           </a:p>
           <a:p>
             <a:pPr lvl="1"/>
             <a:r>
               <a:rPr lang="en-GB" dirty="0"/>
-              <a:t>R vs SQL, what’s the difference?</a:t>
+              <a:t>Learn how to read in data; clean, manipulate and join datasets; plot charts</a:t>
             </a:r>
           </a:p>
           <a:p>
             <a:pPr lvl="1"/>
             <a:r>
               <a:rPr lang="en-GB" dirty="0"/>
-              <a:t>Understanding clearly how this applies to your own work. </a:t>
+              <a:t>Understand how R can be applied to your work</a:t>
             </a:r>
           </a:p>
           <a:p>
             <a:r>
               <a:rPr lang="en-GB" dirty="0"/>
-              <a:t>An understanding of the ways we can use R for RAP processes</a:t>
+              <a:t>Gain understanding of how we can use R for RAP processes</a:t>
             </a:r>
           </a:p>
           <a:p>
             <a:pPr lvl="1"/>
             <a:r>
               <a:rPr lang="en-GB" dirty="0"/>
-              <a:t>Functions</a:t>
+              <a:t>Connecting to databases</a:t>
             </a:r>
           </a:p>
           <a:p>
             <a:pPr lvl="1"/>
             <a:r>
               <a:rPr lang="en-GB" dirty="0"/>
-              <a:t>If statements </a:t>
+              <a:t>Writing functions</a:t>
             </a:r>
           </a:p>
           <a:p>
             <a:pPr lvl="1"/>
             <a:r>
               <a:rPr lang="en-GB" dirty="0"/>
-              <a:t>Wildcards/regex</a:t>
-            </a:r>
-          </a:p>
-          <a:p>
-            <a:pPr lvl="1"/>
-            <a:endParaRPr lang="en-GB" dirty="0"/>
+              <a:t>Using “if” and “if else” statements </a:t>
+            </a:r>
           </a:p>
           <a:p>
             <a:endParaRPr lang="en-GB" dirty="0"/>
@@ -3970,6 +4642,66 @@
           <p:cNvPr id="2" name="Title 1">
             <a:extLst>
               <a:ext uri="{FF2B5EF4-FFF2-40B4-BE49-F238E27FC236}">
+                <a16:creationId xmlns:a16="http://schemas.microsoft.com/office/drawing/2014/main" id="{3F7248CA-32A0-7285-9508-91F31A882237}"/>
+              </a:ext>
+            </a:extLst>
+          </p:cNvPr>
+          <p:cNvSpPr>
+            <a:spLocks noGrp="1"/>
+          </p:cNvSpPr>
+          <p:nvPr>
+            <p:ph type="title"/>
+          </p:nvPr>
+        </p:nvSpPr>
+        <p:spPr/>
+        <p:txBody>
+          <a:bodyPr>
+            <a:normAutofit/>
+          </a:bodyPr>
+          <a:lstStyle/>
+          <a:p>
+            <a:r>
+              <a:rPr lang="en-GB" dirty="0"/>
+              <a:t>Do you have any blockers or pain points with using R?</a:t>
+            </a:r>
+          </a:p>
+        </p:txBody>
+      </p:sp>
+    </p:spTree>
+    <p:extLst>
+      <p:ext uri="{BB962C8B-B14F-4D97-AF65-F5344CB8AC3E}">
+        <p14:creationId xmlns:p14="http://schemas.microsoft.com/office/powerpoint/2010/main" val="313665197"/>
+      </p:ext>
+    </p:extLst>
+  </p:cSld>
+  <p:clrMapOvr>
+    <a:masterClrMapping/>
+  </p:clrMapOvr>
+</p:sld>
+</file>
+
+<file path=ppt/slides/slide4.xml><?xml version="1.0" encoding="utf-8"?>
+<p:sld xmlns:a="http://schemas.openxmlformats.org/drawingml/2006/main" xmlns:r="http://schemas.openxmlformats.org/officeDocument/2006/relationships" xmlns:p="http://schemas.openxmlformats.org/presentationml/2006/main">
+  <p:cSld>
+    <p:spTree>
+      <p:nvGrpSpPr>
+        <p:cNvPr id="1" name=""/>
+        <p:cNvGrpSpPr/>
+        <p:nvPr/>
+      </p:nvGrpSpPr>
+      <p:grpSpPr>
+        <a:xfrm>
+          <a:off x="0" y="0"/>
+          <a:ext cx="0" cy="0"/>
+          <a:chOff x="0" y="0"/>
+          <a:chExt cx="0" cy="0"/>
+        </a:xfrm>
+      </p:grpSpPr>
+      <p:sp>
+        <p:nvSpPr>
+          <p:cNvPr id="2" name="Title 1">
+            <a:extLst>
+              <a:ext uri="{FF2B5EF4-FFF2-40B4-BE49-F238E27FC236}">
                 <a16:creationId xmlns:a16="http://schemas.microsoft.com/office/drawing/2014/main" id="{0CFA85F2-4547-7FBD-E742-54C6CB329011}"/>
               </a:ext>
             </a:extLst>
@@ -3988,7 +4720,7 @@
           <a:p>
             <a:r>
               <a:rPr lang="en-GB" dirty="0"/>
-              <a:t>What are the key blockers to you using R for RAP?</a:t>
+              <a:t>Do you have any blockers or pain points with using R?</a:t>
             </a:r>
           </a:p>
         </p:txBody>
@@ -4016,37 +4748,37 @@
           <a:p>
             <a:r>
               <a:rPr lang="en-GB" dirty="0"/>
-              <a:t>Team or personal expertise/knowledge/capability</a:t>
+              <a:t>Limited team or personal knowledge/capability</a:t>
             </a:r>
           </a:p>
           <a:p>
             <a:r>
               <a:rPr lang="en-GB" dirty="0"/>
-              <a:t>Not enough support in the department</a:t>
+              <a:t>Not enough support within the department</a:t>
             </a:r>
           </a:p>
           <a:p>
             <a:r>
               <a:rPr lang="en-GB" dirty="0"/>
-              <a:t>Challenges in setting it (RStudio) up on work machines and getting it to work (for example, package issues, connecting to databases…).</a:t>
+              <a:t>Challenges in setting up R / RStudio on work laptops and getting it to work, e.g., package issues, connecting to databases…</a:t>
             </a:r>
           </a:p>
           <a:p>
             <a:r>
               <a:rPr lang="en-GB" dirty="0"/>
-              <a:t>Don’t see how it benefits us compared to what we already do (i.e. on SQL or excel)</a:t>
+              <a:t>Don’t see any benefit compared to existing processes, i.e. using SQL or Excel</a:t>
             </a:r>
           </a:p>
           <a:p>
             <a:r>
               <a:rPr lang="en-GB" dirty="0"/>
-              <a:t>Overwhelmed by too much to learn alongside other things (i.e. SQL, Git)</a:t>
+              <a:t>Not enough time to learn it alongside other important skills</a:t>
             </a:r>
           </a:p>
           <a:p>
             <a:r>
               <a:rPr lang="en-GB" dirty="0"/>
-              <a:t>The leap from the learning to the real-life applications is too big.</a:t>
+              <a:t>The leap from the learning to the real-life applications is too big</a:t>
             </a:r>
           </a:p>
           <a:p>
@@ -4391,119 +5123,6 @@
 </p:sld>
 </file>
 
-<file path=ppt/slides/slide4.xml><?xml version="1.0" encoding="utf-8"?>
-<p:sld xmlns:a="http://schemas.openxmlformats.org/drawingml/2006/main" xmlns:r="http://schemas.openxmlformats.org/officeDocument/2006/relationships" xmlns:p="http://schemas.openxmlformats.org/presentationml/2006/main">
-  <p:cSld>
-    <p:spTree>
-      <p:nvGrpSpPr>
-        <p:cNvPr id="1" name=""/>
-        <p:cNvGrpSpPr/>
-        <p:nvPr/>
-      </p:nvGrpSpPr>
-      <p:grpSpPr>
-        <a:xfrm>
-          <a:off x="0" y="0"/>
-          <a:ext cx="0" cy="0"/>
-          <a:chOff x="0" y="0"/>
-          <a:chExt cx="0" cy="0"/>
-        </a:xfrm>
-      </p:grpSpPr>
-      <p:sp>
-        <p:nvSpPr>
-          <p:cNvPr id="2" name="Title 1">
-            <a:extLst>
-              <a:ext uri="{FF2B5EF4-FFF2-40B4-BE49-F238E27FC236}">
-                <a16:creationId xmlns:a16="http://schemas.microsoft.com/office/drawing/2014/main" id="{6FCF0915-82AB-EF2E-6E65-9B4AE665E091}"/>
-              </a:ext>
-            </a:extLst>
-          </p:cNvPr>
-          <p:cNvSpPr>
-            <a:spLocks noGrp="1"/>
-          </p:cNvSpPr>
-          <p:nvPr>
-            <p:ph type="title"/>
-          </p:nvPr>
-        </p:nvSpPr>
-        <p:spPr/>
-        <p:txBody>
-          <a:bodyPr/>
-          <a:lstStyle/>
-          <a:p>
-            <a:r>
-              <a:rPr lang="en-GB" dirty="0"/>
-              <a:t>What is R?</a:t>
-            </a:r>
-          </a:p>
-        </p:txBody>
-      </p:sp>
-      <p:sp>
-        <p:nvSpPr>
-          <p:cNvPr id="3" name="Content Placeholder 2">
-            <a:extLst>
-              <a:ext uri="{FF2B5EF4-FFF2-40B4-BE49-F238E27FC236}">
-                <a16:creationId xmlns:a16="http://schemas.microsoft.com/office/drawing/2014/main" id="{4DC9CE65-9442-8FB9-7571-B418217290A2}"/>
-              </a:ext>
-            </a:extLst>
-          </p:cNvPr>
-          <p:cNvSpPr>
-            <a:spLocks noGrp="1"/>
-          </p:cNvSpPr>
-          <p:nvPr>
-            <p:ph idx="1"/>
-          </p:nvPr>
-        </p:nvSpPr>
-        <p:spPr/>
-        <p:txBody>
-          <a:bodyPr/>
-          <a:lstStyle/>
-          <a:p>
-            <a:r>
-              <a:rPr lang="en-GB" dirty="0"/>
-              <a:t>R is a coding language. There are many different languages of code, some others include SQL, python, JavaScript and many more. They all have benefits, and the difference is often the syntax used (literally like learning new languages!) </a:t>
-            </a:r>
-          </a:p>
-          <a:p>
-            <a:r>
-              <a:rPr lang="en-GB" dirty="0"/>
-              <a:t>R is open-source, meaning it is free, anyone can use it and anyone can contribute to developing new ‘packages’.</a:t>
-            </a:r>
-          </a:p>
-          <a:p>
-            <a:pPr lvl="1"/>
-            <a:r>
-              <a:rPr lang="en-GB" dirty="0"/>
-              <a:t>A package is a set of functions someone else has written and tied together in a nice neat bow, ready for you to use! You simply install the package, and then you have all of the functions available. </a:t>
-            </a:r>
-          </a:p>
-          <a:p>
-            <a:pPr lvl="1"/>
-            <a:r>
-              <a:rPr lang="en-GB" dirty="0"/>
-              <a:t>A function is a chunk of code that has been grouped together, given a name, and often has ‘place holders’ you can change, such that you can use that name to run that code, and apply it to different data. </a:t>
-            </a:r>
-          </a:p>
-          <a:p>
-            <a:pPr lvl="2"/>
-            <a:r>
-              <a:rPr lang="en-GB" dirty="0"/>
-              <a:t>(for example, mean(x) is a function that calculates the arithmetic mean of x. You replace x with any numeric data.)</a:t>
-            </a:r>
-          </a:p>
-        </p:txBody>
-      </p:sp>
-    </p:spTree>
-    <p:extLst>
-      <p:ext uri="{BB962C8B-B14F-4D97-AF65-F5344CB8AC3E}">
-        <p14:creationId xmlns:p14="http://schemas.microsoft.com/office/powerpoint/2010/main" val="4123275360"/>
-      </p:ext>
-    </p:extLst>
-  </p:cSld>
-  <p:clrMapOvr>
-    <a:masterClrMapping/>
-  </p:clrMapOvr>
-</p:sld>
-</file>
-
 <file path=ppt/slides/slide5.xml><?xml version="1.0" encoding="utf-8"?>
 <p:sld xmlns:a="http://schemas.openxmlformats.org/drawingml/2006/main" xmlns:r="http://schemas.openxmlformats.org/officeDocument/2006/relationships" xmlns:p="http://schemas.openxmlformats.org/presentationml/2006/main">
   <p:cSld>
@@ -4526,7 +5145,7 @@
           <p:cNvPr id="2" name="Title 1">
             <a:extLst>
               <a:ext uri="{FF2B5EF4-FFF2-40B4-BE49-F238E27FC236}">
-                <a16:creationId xmlns:a16="http://schemas.microsoft.com/office/drawing/2014/main" id="{330580FA-7B1A-DE39-0F93-0C03FAEDEE67}"/>
+                <a16:creationId xmlns:a16="http://schemas.microsoft.com/office/drawing/2014/main" id="{6FCF0915-82AB-EF2E-6E65-9B4AE665E091}"/>
               </a:ext>
             </a:extLst>
           </p:cNvPr>
@@ -4544,7 +5163,7 @@
           <a:p>
             <a:r>
               <a:rPr lang="en-GB" dirty="0"/>
-              <a:t>R vs SQL</a:t>
+              <a:t>What is R?</a:t>
             </a:r>
           </a:p>
         </p:txBody>
@@ -4554,7 +5173,7 @@
           <p:cNvPr id="3" name="Content Placeholder 2">
             <a:extLst>
               <a:ext uri="{FF2B5EF4-FFF2-40B4-BE49-F238E27FC236}">
-                <a16:creationId xmlns:a16="http://schemas.microsoft.com/office/drawing/2014/main" id="{DF523CBC-ADD1-9D52-C075-DB785A34D736}"/>
+                <a16:creationId xmlns:a16="http://schemas.microsoft.com/office/drawing/2014/main" id="{4DC9CE65-9442-8FB9-7571-B418217290A2}"/>
               </a:ext>
             </a:extLst>
           </p:cNvPr>
@@ -4567,26 +5186,39 @@
         </p:nvSpPr>
         <p:spPr/>
         <p:txBody>
-          <a:bodyPr>
-            <a:normAutofit/>
-          </a:bodyPr>
+          <a:bodyPr/>
           <a:lstStyle/>
           <a:p>
             <a:r>
               <a:rPr lang="en-GB" dirty="0"/>
-              <a:t>R and SQL are two different coding languages, but if you already know one, it can make it easier to learn the other as the logic tends to be similar even if the syntax is different. </a:t>
+              <a:t>R is a coding language. There are many different languages of code, some others include SQL, python, JavaScript and many more. They all have benefits, and the difference is often the syntax used (literally like learning new languages!) </a:t>
             </a:r>
           </a:p>
           <a:p>
             <a:r>
               <a:rPr lang="en-GB" dirty="0"/>
-              <a:t>SQL runs processes on the database server, whereas R runs processes on your device. Therefore we recommend doing large scale processing on the SQL/database side, and then only bring the data you need for manipulation/ complicated processing into R. </a:t>
-            </a:r>
-          </a:p>
-          <a:p>
+              <a:t>R is open-source, meaning it is free, anyone can use it and anyone can contribute to developing new ‘packages’</a:t>
+            </a:r>
+          </a:p>
+          <a:p>
+            <a:pPr lvl="1"/>
             <a:r>
               <a:rPr lang="en-GB" dirty="0"/>
-              <a:t>There’s a grey area in the middle where you can do some things in either tool, sometimes you’ll need to test yourself which way is faster. Remember that SQL code can be run through R, so you can have a mixture of scripts, you should still have a ‘centralised’ R script that will run and source both your SQL and R scripts, in order! </a:t>
+              <a:t>A package is a set of functions someone else has written and tied together in a nice neat bow, ready for you to use. By installing the package you’ll have all of those functions available</a:t>
+            </a:r>
+          </a:p>
+          <a:p>
+            <a:pPr lvl="1"/>
+            <a:r>
+              <a:rPr lang="en-GB" dirty="0"/>
+              <a:t>A function is a chunk of code that has been grouped together, given a name, and often has ‘place holders’ you can change to apply it to different data </a:t>
+            </a:r>
+          </a:p>
+          <a:p>
+            <a:pPr lvl="2"/>
+            <a:r>
+              <a:rPr lang="en-GB" dirty="0"/>
+              <a:t>E.g., mean(x) is a function that calculates the arithmetic mean of x, where x can be replaced with any numeric data</a:t>
             </a:r>
           </a:p>
         </p:txBody>
@@ -4594,7 +5226,7 @@
     </p:spTree>
     <p:extLst>
       <p:ext uri="{BB962C8B-B14F-4D97-AF65-F5344CB8AC3E}">
-        <p14:creationId xmlns:p14="http://schemas.microsoft.com/office/powerpoint/2010/main" val="3050567684"/>
+        <p14:creationId xmlns:p14="http://schemas.microsoft.com/office/powerpoint/2010/main" val="4123275360"/>
       </p:ext>
     </p:extLst>
   </p:cSld>
@@ -4626,6 +5258,106 @@
           <p:cNvPr id="2" name="Title 1">
             <a:extLst>
               <a:ext uri="{FF2B5EF4-FFF2-40B4-BE49-F238E27FC236}">
+                <a16:creationId xmlns:a16="http://schemas.microsoft.com/office/drawing/2014/main" id="{330580FA-7B1A-DE39-0F93-0C03FAEDEE67}"/>
+              </a:ext>
+            </a:extLst>
+          </p:cNvPr>
+          <p:cNvSpPr>
+            <a:spLocks noGrp="1"/>
+          </p:cNvSpPr>
+          <p:nvPr>
+            <p:ph type="title"/>
+          </p:nvPr>
+        </p:nvSpPr>
+        <p:spPr/>
+        <p:txBody>
+          <a:bodyPr/>
+          <a:lstStyle/>
+          <a:p>
+            <a:r>
+              <a:rPr lang="en-GB" dirty="0"/>
+              <a:t>R vs SQL</a:t>
+            </a:r>
+          </a:p>
+        </p:txBody>
+      </p:sp>
+      <p:sp>
+        <p:nvSpPr>
+          <p:cNvPr id="3" name="Content Placeholder 2">
+            <a:extLst>
+              <a:ext uri="{FF2B5EF4-FFF2-40B4-BE49-F238E27FC236}">
+                <a16:creationId xmlns:a16="http://schemas.microsoft.com/office/drawing/2014/main" id="{DF523CBC-ADD1-9D52-C075-DB785A34D736}"/>
+              </a:ext>
+            </a:extLst>
+          </p:cNvPr>
+          <p:cNvSpPr>
+            <a:spLocks noGrp="1"/>
+          </p:cNvSpPr>
+          <p:nvPr>
+            <p:ph idx="1"/>
+          </p:nvPr>
+        </p:nvSpPr>
+        <p:spPr/>
+        <p:txBody>
+          <a:bodyPr>
+            <a:normAutofit/>
+          </a:bodyPr>
+          <a:lstStyle/>
+          <a:p>
+            <a:r>
+              <a:rPr lang="en-GB" dirty="0"/>
+              <a:t>R and SQL are two different coding languages, but if you already know one, it can make it easier to learn the other as the logic tends to be similar even if the syntax is different</a:t>
+            </a:r>
+          </a:p>
+          <a:p>
+            <a:r>
+              <a:rPr lang="en-GB" dirty="0"/>
+              <a:t>SQL runs processes on a database server, whereas R runs processes on your computer. We recommend doing large scale processing on SQL and then bringing only the data you need for complicated manipulation into R</a:t>
+            </a:r>
+          </a:p>
+          <a:p>
+            <a:r>
+              <a:rPr lang="en-GB" dirty="0"/>
+              <a:t>There’s a grey area in the middle where you can do some things in either tool, sometimes you’ll need to test yourself which way is faster. SQL code can be run through R so you can have a mixture of scripts across the two languages. You should have a ‘centralised’ R script that will run and source both your SQL and R scripts in order </a:t>
+            </a:r>
+          </a:p>
+        </p:txBody>
+      </p:sp>
+    </p:spTree>
+    <p:extLst>
+      <p:ext uri="{BB962C8B-B14F-4D97-AF65-F5344CB8AC3E}">
+        <p14:creationId xmlns:p14="http://schemas.microsoft.com/office/powerpoint/2010/main" val="3050567684"/>
+      </p:ext>
+    </p:extLst>
+  </p:cSld>
+  <p:clrMapOvr>
+    <a:masterClrMapping/>
+  </p:clrMapOvr>
+</p:sld>
+</file>
+
+<file path=ppt/slides/slide7.xml><?xml version="1.0" encoding="utf-8"?>
+<p:sld xmlns:a="http://schemas.openxmlformats.org/drawingml/2006/main" xmlns:r="http://schemas.openxmlformats.org/officeDocument/2006/relationships" xmlns:p="http://schemas.openxmlformats.org/presentationml/2006/main">
+  <p:cSld>
+    <p:spTree>
+      <p:nvGrpSpPr>
+        <p:cNvPr id="1" name=""/>
+        <p:cNvGrpSpPr/>
+        <p:nvPr/>
+      </p:nvGrpSpPr>
+      <p:grpSpPr>
+        <a:xfrm>
+          <a:off x="0" y="0"/>
+          <a:ext cx="0" cy="0"/>
+          <a:chOff x="0" y="0"/>
+          <a:chExt cx="0" cy="0"/>
+        </a:xfrm>
+      </p:grpSpPr>
+      <p:sp>
+        <p:nvSpPr>
+          <p:cNvPr id="2" name="Title 1">
+            <a:extLst>
+              <a:ext uri="{FF2B5EF4-FFF2-40B4-BE49-F238E27FC236}">
                 <a16:creationId xmlns:a16="http://schemas.microsoft.com/office/drawing/2014/main" id="{791C52A6-7C0D-DCB9-CDEB-D8500751A713}"/>
               </a:ext>
             </a:extLst>
@@ -4637,14 +5369,19 @@
             <p:ph type="title"/>
           </p:nvPr>
         </p:nvSpPr>
-        <p:spPr/>
+        <p:spPr>
+          <a:xfrm>
+            <a:off x="1261872" y="365760"/>
+            <a:ext cx="9692640" cy="861623"/>
+          </a:xfrm>
+        </p:spPr>
         <p:txBody>
           <a:bodyPr/>
           <a:lstStyle/>
           <a:p>
             <a:r>
               <a:rPr lang="en-GB" dirty="0"/>
-              <a:t>R studio</a:t>
+              <a:t>RStudio</a:t>
             </a:r>
           </a:p>
         </p:txBody>
@@ -4665,14 +5402,25 @@
             <p:ph idx="1"/>
           </p:nvPr>
         </p:nvSpPr>
-        <p:spPr/>
+        <p:spPr>
+          <a:xfrm>
+            <a:off x="1261872" y="1315594"/>
+            <a:ext cx="8595360" cy="4864544"/>
+          </a:xfrm>
+        </p:spPr>
         <p:txBody>
           <a:bodyPr/>
           <a:lstStyle/>
           <a:p>
             <a:r>
               <a:rPr lang="en-GB" dirty="0"/>
-              <a:t>R studio is a programme that enables us to code in the R coding language, while also providing a visual and interactive interface. It has useful areas and windows that enable you to see what tables you have loaded, charts you have created, Git user interface, file explorer, help windows and many more!</a:t>
+              <a:t>RStudio is a programme that enables us to code in the R coding language, while also providing a visual and interactive interface. </a:t>
+            </a:r>
+          </a:p>
+          <a:p>
+            <a:r>
+              <a:rPr lang="en-GB" dirty="0"/>
+              <a:t>It has useful windows that enable you to see the tables you have loaded, charts you have created, Git user interface, file explorer, help windows and more!</a:t>
             </a:r>
           </a:p>
           <a:p>
@@ -4938,7 +5686,7 @@
         </p:nvSpPr>
         <p:spPr>
           <a:xfrm>
-            <a:off x="637563" y="3741005"/>
+            <a:off x="688022" y="4115637"/>
             <a:ext cx="1697205" cy="830997"/>
           </a:xfrm>
           <a:prstGeom prst="rect">
@@ -4953,12 +5701,8 @@
           <a:lstStyle/>
           <a:p>
             <a:r>
-              <a:rPr lang="en-GB" sz="1200" dirty="0">
-                <a:solidFill>
-                  <a:srgbClr val="FF0000"/>
-                </a:solidFill>
-              </a:rPr>
-              <a:t>1: Source pane. Open and view your code scripts, tables, data sets, functions. </a:t>
+              <a:rPr lang="en-GB" sz="1200" dirty="0"/>
+              <a:t>1: Source pane: open and view your code scripts, tables, data sets, functions. </a:t>
             </a:r>
           </a:p>
         </p:txBody>
@@ -4977,7 +5721,7 @@
         </p:nvSpPr>
         <p:spPr>
           <a:xfrm>
-            <a:off x="637563" y="5406238"/>
+            <a:off x="688022" y="5395950"/>
             <a:ext cx="1798125" cy="1200329"/>
           </a:xfrm>
           <a:prstGeom prst="rect">
@@ -4992,12 +5736,8 @@
           <a:lstStyle/>
           <a:p>
             <a:r>
-              <a:rPr lang="en-GB" sz="1200" dirty="0">
-                <a:solidFill>
-                  <a:srgbClr val="FF0000"/>
-                </a:solidFill>
-              </a:rPr>
-              <a:t>2: Console. Shows what you have run, and you can type and run commands directly into the console. </a:t>
+              <a:rPr lang="en-GB" sz="1200" dirty="0"/>
+              <a:t>2: Console: shows what you have run, and you can type and run commands directly into the console. </a:t>
             </a:r>
           </a:p>
         </p:txBody>
@@ -5016,8 +5756,8 @@
         </p:nvSpPr>
         <p:spPr>
           <a:xfrm>
-            <a:off x="7896751" y="3616680"/>
-            <a:ext cx="2944579" cy="1015663"/>
+            <a:off x="7941152" y="3859747"/>
+            <a:ext cx="2944579" cy="830997"/>
           </a:xfrm>
           <a:prstGeom prst="rect">
             <a:avLst/>
@@ -5031,22 +5771,8 @@
           <a:lstStyle/>
           <a:p>
             <a:r>
-              <a:rPr lang="en-GB" sz="1200" dirty="0">
-                <a:solidFill>
-                  <a:srgbClr val="FF0000"/>
-                </a:solidFill>
-              </a:rPr>
-              <a:t>3: Environment/History/Connections/Git (if you have it)</a:t>
-            </a:r>
-          </a:p>
-          <a:p>
-            <a:r>
-              <a:rPr lang="en-GB" sz="1200" dirty="0">
-                <a:solidFill>
-                  <a:srgbClr val="FF0000"/>
-                </a:solidFill>
-              </a:rPr>
-              <a:t>The environment shows you what data, functions, objects etc you have.</a:t>
+              <a:rPr lang="en-GB" sz="1200" dirty="0"/>
+              <a:t>3: Environment / History / Connections / Git (if you have it): the environment shows you what data, functions, objects etc you have.</a:t>
             </a:r>
           </a:p>
         </p:txBody>
@@ -5065,8 +5791,8 @@
         </p:nvSpPr>
         <p:spPr>
           <a:xfrm>
-            <a:off x="7892893" y="4954280"/>
-            <a:ext cx="2944579" cy="276999"/>
+            <a:off x="7960428" y="5544737"/>
+            <a:ext cx="2944579" cy="461665"/>
           </a:xfrm>
           <a:prstGeom prst="rect">
             <a:avLst/>
@@ -5080,12 +5806,8 @@
           <a:lstStyle/>
           <a:p>
             <a:r>
-              <a:rPr lang="en-GB" sz="1200" dirty="0">
-                <a:solidFill>
-                  <a:srgbClr val="FF0000"/>
-                </a:solidFill>
-              </a:rPr>
-              <a:t>4: File explorer/plots/packages/Viewer.</a:t>
+              <a:rPr lang="en-GB" sz="1200" dirty="0"/>
+              <a:t>4: File explorer / plots / packages / viewer.</a:t>
             </a:r>
           </a:p>
         </p:txBody>
@@ -5094,151 +5816,6 @@
     <p:extLst>
       <p:ext uri="{BB962C8B-B14F-4D97-AF65-F5344CB8AC3E}">
         <p14:creationId xmlns:p14="http://schemas.microsoft.com/office/powerpoint/2010/main" val="3863786096"/>
-      </p:ext>
-    </p:extLst>
-  </p:cSld>
-  <p:clrMapOvr>
-    <a:masterClrMapping/>
-  </p:clrMapOvr>
-</p:sld>
-</file>
-
-<file path=ppt/slides/slide7.xml><?xml version="1.0" encoding="utf-8"?>
-<p:sld xmlns:a="http://schemas.openxmlformats.org/drawingml/2006/main" xmlns:r="http://schemas.openxmlformats.org/officeDocument/2006/relationships" xmlns:p="http://schemas.openxmlformats.org/presentationml/2006/main">
-  <p:cSld>
-    <p:spTree>
-      <p:nvGrpSpPr>
-        <p:cNvPr id="1" name=""/>
-        <p:cNvGrpSpPr/>
-        <p:nvPr/>
-      </p:nvGrpSpPr>
-      <p:grpSpPr>
-        <a:xfrm>
-          <a:off x="0" y="0"/>
-          <a:ext cx="0" cy="0"/>
-          <a:chOff x="0" y="0"/>
-          <a:chExt cx="0" cy="0"/>
-        </a:xfrm>
-      </p:grpSpPr>
-      <p:sp>
-        <p:nvSpPr>
-          <p:cNvPr id="2" name="Title 1">
-            <a:extLst>
-              <a:ext uri="{FF2B5EF4-FFF2-40B4-BE49-F238E27FC236}">
-                <a16:creationId xmlns:a16="http://schemas.microsoft.com/office/drawing/2014/main" id="{DD7F82BF-1B0B-A48E-3017-2E93FCD61287}"/>
-              </a:ext>
-            </a:extLst>
-          </p:cNvPr>
-          <p:cNvSpPr>
-            <a:spLocks noGrp="1"/>
-          </p:cNvSpPr>
-          <p:nvPr>
-            <p:ph type="title"/>
-          </p:nvPr>
-        </p:nvSpPr>
-        <p:spPr/>
-        <p:txBody>
-          <a:bodyPr/>
-          <a:lstStyle/>
-          <a:p>
-            <a:r>
-              <a:rPr lang="en-GB" dirty="0"/>
-              <a:t>What is RAP?</a:t>
-            </a:r>
-          </a:p>
-        </p:txBody>
-      </p:sp>
-      <p:sp>
-        <p:nvSpPr>
-          <p:cNvPr id="3" name="Content Placeholder 2">
-            <a:extLst>
-              <a:ext uri="{FF2B5EF4-FFF2-40B4-BE49-F238E27FC236}">
-                <a16:creationId xmlns:a16="http://schemas.microsoft.com/office/drawing/2014/main" id="{D23D0DCF-B52A-51B9-E9E1-B1BF01360E12}"/>
-              </a:ext>
-            </a:extLst>
-          </p:cNvPr>
-          <p:cNvSpPr>
-            <a:spLocks noGrp="1"/>
-          </p:cNvSpPr>
-          <p:nvPr>
-            <p:ph idx="1"/>
-          </p:nvPr>
-        </p:nvSpPr>
-        <p:spPr/>
-        <p:txBody>
-          <a:bodyPr>
-            <a:normAutofit lnSpcReduction="10000"/>
-          </a:bodyPr>
-          <a:lstStyle/>
-          <a:p>
-            <a:r>
-              <a:rPr lang="en-GB" dirty="0"/>
-              <a:t>RAP stands for </a:t>
-            </a:r>
-            <a:r>
-              <a:rPr lang="en-GB" b="1" u="sng" dirty="0"/>
-              <a:t>R</a:t>
-            </a:r>
-            <a:r>
-              <a:rPr lang="en-GB" dirty="0"/>
-              <a:t>eproducible </a:t>
-            </a:r>
-            <a:r>
-              <a:rPr lang="en-GB" b="1" u="sng" dirty="0"/>
-              <a:t>A</a:t>
-            </a:r>
-            <a:r>
-              <a:rPr lang="en-GB" dirty="0"/>
-              <a:t>nalytical </a:t>
-            </a:r>
-            <a:r>
-              <a:rPr lang="en-GB" b="1" u="sng" dirty="0"/>
-              <a:t>P</a:t>
-            </a:r>
-            <a:r>
-              <a:rPr lang="en-GB" dirty="0"/>
-              <a:t>ipeline. The full words still hide the true meaning behind buzzwords and jargon though. What it actually means is using automation to our advantage when analysing data (this is as simple as writing code such as an R script that we can click a button to execute and do the job for us), and ensuring we are transparent. </a:t>
-            </a:r>
-          </a:p>
-          <a:p>
-            <a:r>
-              <a:rPr lang="en-GB" dirty="0"/>
-              <a:t>Using R (the coding language) really helps us to put the R in RAP ('reproducible'). Ask yourself, </a:t>
-            </a:r>
-          </a:p>
-          <a:p>
-            <a:pPr lvl="1"/>
-            <a:r>
-              <a:rPr lang="en-GB" dirty="0"/>
-              <a:t>If someone else picked up your work, could they easily reproduce your exact outputs? </a:t>
-            </a:r>
-          </a:p>
-          <a:p>
-            <a:pPr lvl="1"/>
-            <a:r>
-              <a:rPr lang="en-GB" dirty="0"/>
-              <a:t>When the time comes around to update your analysis with new data, how easy is it for you to reproduce the analysis you need? </a:t>
-            </a:r>
-          </a:p>
-          <a:p>
-            <a:pPr lvl="1"/>
-            <a:r>
-              <a:rPr lang="en-GB" dirty="0"/>
-              <a:t>Can the public reproduce your analysis?</a:t>
-            </a:r>
-          </a:p>
-          <a:p>
-            <a:r>
-              <a:rPr lang="en-GB" dirty="0"/>
-              <a:t>In an ideal RAP, it would be as simple as plugging the new data in and clicking 'go', with no need to manually scroll through multiple scripts updating the year in every file name or the variable name that's changed from using _ to -.</a:t>
-            </a:r>
-          </a:p>
-        </p:txBody>
-      </p:sp>
-    </p:spTree>
-    <p:extLst>
-      <p:ext uri="{BB962C8B-B14F-4D97-AF65-F5344CB8AC3E}">
-        <p14:creationId xmlns:p14="http://schemas.microsoft.com/office/powerpoint/2010/main" val="1410471086"/>
       </p:ext>
     </p:extLst>
   </p:cSld>
@@ -5270,7 +5847,7 @@
           <p:cNvPr id="2" name="Title 1">
             <a:extLst>
               <a:ext uri="{FF2B5EF4-FFF2-40B4-BE49-F238E27FC236}">
-                <a16:creationId xmlns:a16="http://schemas.microsoft.com/office/drawing/2014/main" id="{4EBAFED2-1C42-5651-163B-8818BBF3005F}"/>
+                <a16:creationId xmlns:a16="http://schemas.microsoft.com/office/drawing/2014/main" id="{DD7F82BF-1B0B-A48E-3017-2E93FCD61287}"/>
               </a:ext>
             </a:extLst>
           </p:cNvPr>
@@ -5288,7 +5865,7 @@
           <a:p>
             <a:r>
               <a:rPr lang="en-GB" dirty="0"/>
-              <a:t>What are the benefits?</a:t>
+              <a:t>What is RAP?</a:t>
             </a:r>
           </a:p>
         </p:txBody>
@@ -5298,7 +5875,7 @@
           <p:cNvPr id="3" name="Content Placeholder 2">
             <a:extLst>
               <a:ext uri="{FF2B5EF4-FFF2-40B4-BE49-F238E27FC236}">
-                <a16:creationId xmlns:a16="http://schemas.microsoft.com/office/drawing/2014/main" id="{F3EFC132-8AC8-5B25-3629-B38C66AF4818}"/>
+                <a16:creationId xmlns:a16="http://schemas.microsoft.com/office/drawing/2014/main" id="{D23D0DCF-B52A-51B9-E9E1-B1BF01360E12}"/>
               </a:ext>
             </a:extLst>
           </p:cNvPr>
@@ -5311,45 +5888,78 @@
         </p:nvSpPr>
         <p:spPr/>
         <p:txBody>
-          <a:bodyPr/>
+          <a:bodyPr>
+            <a:normAutofit/>
+          </a:bodyPr>
           <a:lstStyle/>
           <a:p>
             <a:r>
               <a:rPr lang="en-GB" dirty="0"/>
-              <a:t>We already have ‘analytical pipelines’ and have done for many years. The aim of RAP is to;</a:t>
+              <a:t>RAP stands for </a:t>
+            </a:r>
+            <a:r>
+              <a:rPr lang="en-GB" b="1" u="sng" dirty="0"/>
+              <a:t>R</a:t>
+            </a:r>
+            <a:r>
+              <a:rPr lang="en-GB" dirty="0"/>
+              <a:t>eproducible </a:t>
+            </a:r>
+            <a:r>
+              <a:rPr lang="en-GB" b="1" u="sng" dirty="0"/>
+              <a:t>A</a:t>
+            </a:r>
+            <a:r>
+              <a:rPr lang="en-GB" dirty="0"/>
+              <a:t>nalytical </a:t>
+            </a:r>
+            <a:r>
+              <a:rPr lang="en-GB" b="1" u="sng" dirty="0"/>
+              <a:t>P</a:t>
+            </a:r>
+            <a:r>
+              <a:rPr lang="en-GB" dirty="0"/>
+              <a:t>ipeline</a:t>
             </a:r>
           </a:p>
           <a:p>
             <a:pPr lvl="1"/>
             <a:r>
               <a:rPr lang="en-GB" dirty="0"/>
-              <a:t>Automate the parts of these pipelines that can be automated,</a:t>
+              <a:t>This really means using automation to our advantage when analysing data (this could mean writing an R script that carries out analysis at just the click of a button), and ensuring we are transparent</a:t>
+            </a:r>
+          </a:p>
+          <a:p>
+            <a:r>
+              <a:rPr lang="en-GB" dirty="0"/>
+              <a:t>Using R really helps us to put the R (for reproducible) in RAP. Ask yourself: </a:t>
             </a:r>
           </a:p>
           <a:p>
             <a:pPr lvl="1"/>
             <a:r>
               <a:rPr lang="en-GB" dirty="0"/>
-              <a:t>Increase efficiency and accuracy, </a:t>
+              <a:t>Could someone new to your work easily reproduce your exact outputs?</a:t>
             </a:r>
           </a:p>
           <a:p>
             <a:pPr lvl="1"/>
             <a:r>
               <a:rPr lang="en-GB" dirty="0"/>
-              <a:t>Create a clear audit trail to allow analyses to easily be re-run if needed. </a:t>
-            </a:r>
-          </a:p>
-          <a:p>
+              <a:t>How easy is it to reproduce your analysis using new data? </a:t>
+            </a:r>
+          </a:p>
+          <a:p>
+            <a:pPr lvl="1"/>
             <a:r>
               <a:rPr lang="en-GB" dirty="0"/>
-              <a:t>This will free us up to focus on the parts of our work where our human input can really add value. </a:t>
+              <a:t>Can the public reproduce your analysis?</a:t>
             </a:r>
           </a:p>
           <a:p>
             <a:r>
               <a:rPr lang="en-GB" dirty="0"/>
-              <a:t>RAP is something we can use to reduce the burden on us by getting rid of some of the boring stuff, what’s not to like!</a:t>
+              <a:t>In an ideal RAP, it would be as simple as plugging the new data in and clicking 'go', with no need to manually scroll through multiple scripts updating year, file names or variable names</a:t>
             </a:r>
           </a:p>
         </p:txBody>
@@ -5357,7 +5967,7 @@
     </p:spTree>
     <p:extLst>
       <p:ext uri="{BB962C8B-B14F-4D97-AF65-F5344CB8AC3E}">
-        <p14:creationId xmlns:p14="http://schemas.microsoft.com/office/powerpoint/2010/main" val="1286926439"/>
+        <p14:creationId xmlns:p14="http://schemas.microsoft.com/office/powerpoint/2010/main" val="1410471086"/>
       </p:ext>
     </p:extLst>
   </p:cSld>
@@ -5389,7 +5999,7 @@
           <p:cNvPr id="2" name="Title 1">
             <a:extLst>
               <a:ext uri="{FF2B5EF4-FFF2-40B4-BE49-F238E27FC236}">
-                <a16:creationId xmlns:a16="http://schemas.microsoft.com/office/drawing/2014/main" id="{70271C04-0C12-C285-3E1B-74430A28B31B}"/>
+                <a16:creationId xmlns:a16="http://schemas.microsoft.com/office/drawing/2014/main" id="{4EBAFED2-1C42-5651-163B-8818BBF3005F}"/>
               </a:ext>
             </a:extLst>
           </p:cNvPr>
@@ -5405,152 +6015,78 @@
           <a:bodyPr/>
           <a:lstStyle/>
           <a:p>
-            <a:endParaRPr lang="en-GB"/>
-          </a:p>
-        </p:txBody>
-      </p:sp>
-      <p:pic>
-        <p:nvPicPr>
-          <p:cNvPr id="1026" name="Picture 2">
+            <a:r>
+              <a:rPr lang="en-GB" dirty="0"/>
+              <a:t>What are the benefits?</a:t>
+            </a:r>
+          </a:p>
+        </p:txBody>
+      </p:sp>
+      <p:sp>
+        <p:nvSpPr>
+          <p:cNvPr id="3" name="Content Placeholder 2">
             <a:extLst>
               <a:ext uri="{FF2B5EF4-FFF2-40B4-BE49-F238E27FC236}">
-                <a16:creationId xmlns:a16="http://schemas.microsoft.com/office/drawing/2014/main" id="{1F58B4BF-6286-D367-F8C0-6BBF6985DAFE}"/>
+                <a16:creationId xmlns:a16="http://schemas.microsoft.com/office/drawing/2014/main" id="{F3EFC132-8AC8-5B25-3629-B38C66AF4818}"/>
               </a:ext>
             </a:extLst>
           </p:cNvPr>
-          <p:cNvPicPr>
-            <a:picLocks noGrp="1" noChangeAspect="1" noChangeArrowheads="1"/>
-          </p:cNvPicPr>
+          <p:cNvSpPr>
+            <a:spLocks noGrp="1"/>
+          </p:cNvSpPr>
           <p:nvPr>
             <p:ph idx="1"/>
           </p:nvPr>
-        </p:nvPicPr>
-        <p:blipFill>
-          <a:blip r:embed="rId2">
-            <a:extLst>
-              <a:ext uri="{28A0092B-C50C-407E-A947-70E740481C1C}">
-                <a14:useLocalDpi xmlns:a14="http://schemas.microsoft.com/office/drawing/2010/main" val="0"/>
-              </a:ext>
-            </a:extLst>
-          </a:blip>
-          <a:srcRect/>
-          <a:stretch>
-            <a:fillRect/>
-          </a:stretch>
-        </p:blipFill>
-        <p:spPr bwMode="auto">
-          <a:xfrm>
-            <a:off x="1798637" y="97808"/>
-            <a:ext cx="8594725" cy="3331192"/>
-          </a:xfrm>
-          <a:prstGeom prst="rect">
-            <a:avLst/>
-          </a:prstGeom>
-          <a:noFill/>
-          <a:extLst>
-            <a:ext uri="{909E8E84-426E-40DD-AFC4-6F175D3DCCD1}">
-              <a14:hiddenFill xmlns:a14="http://schemas.microsoft.com/office/drawing/2010/main">
-                <a:solidFill>
-                  <a:srgbClr val="FFFFFF"/>
-                </a:solidFill>
-              </a14:hiddenFill>
-            </a:ext>
-          </a:extLst>
-        </p:spPr>
-      </p:pic>
-      <p:pic>
-        <p:nvPicPr>
-          <p:cNvPr id="1028" name="Picture 4">
-            <a:extLst>
-              <a:ext uri="{FF2B5EF4-FFF2-40B4-BE49-F238E27FC236}">
-                <a16:creationId xmlns:a16="http://schemas.microsoft.com/office/drawing/2014/main" id="{E87C30D8-DFD5-36C0-25BD-581F08C05B3F}"/>
-              </a:ext>
-            </a:extLst>
-          </p:cNvPr>
-          <p:cNvPicPr>
-            <a:picLocks noChangeAspect="1" noChangeArrowheads="1"/>
-          </p:cNvPicPr>
-          <p:nvPr/>
-        </p:nvPicPr>
-        <p:blipFill>
-          <a:blip r:embed="rId3">
-            <a:extLst>
-              <a:ext uri="{28A0092B-C50C-407E-A947-70E740481C1C}">
-                <a14:useLocalDpi xmlns:a14="http://schemas.microsoft.com/office/drawing/2010/main" val="0"/>
-              </a:ext>
-            </a:extLst>
-          </a:blip>
-          <a:srcRect/>
-          <a:stretch>
-            <a:fillRect/>
-          </a:stretch>
-        </p:blipFill>
-        <p:spPr bwMode="auto">
-          <a:xfrm>
-            <a:off x="618743" y="4848120"/>
-            <a:ext cx="10954512" cy="1683115"/>
-          </a:xfrm>
-          <a:prstGeom prst="rect">
-            <a:avLst/>
-          </a:prstGeom>
-          <a:noFill/>
-          <a:extLst>
-            <a:ext uri="{909E8E84-426E-40DD-AFC4-6F175D3DCCD1}">
-              <a14:hiddenFill xmlns:a14="http://schemas.microsoft.com/office/drawing/2010/main">
-                <a:solidFill>
-                  <a:srgbClr val="FFFFFF"/>
-                </a:solidFill>
-              </a14:hiddenFill>
-            </a:ext>
-          </a:extLst>
-        </p:spPr>
-      </p:pic>
-      <p:cxnSp>
-        <p:nvCxnSpPr>
-          <p:cNvPr id="5" name="Straight Arrow Connector 4">
-            <a:extLst>
-              <a:ext uri="{FF2B5EF4-FFF2-40B4-BE49-F238E27FC236}">
-                <a16:creationId xmlns:a16="http://schemas.microsoft.com/office/drawing/2014/main" id="{1E32565E-5CB9-A305-C4C9-7AA771471C03}"/>
-              </a:ext>
-            </a:extLst>
-          </p:cNvPr>
-          <p:cNvCxnSpPr/>
-          <p:nvPr/>
-        </p:nvCxnSpPr>
-        <p:spPr>
-          <a:xfrm>
-            <a:off x="6108192" y="3614468"/>
-            <a:ext cx="0" cy="1052423"/>
-          </a:xfrm>
-          <a:prstGeom prst="straightConnector1">
-            <a:avLst/>
-          </a:prstGeom>
-          <a:ln w="76200">
-            <a:solidFill>
-              <a:schemeClr val="tx1"/>
-            </a:solidFill>
-            <a:tailEnd type="triangle"/>
-          </a:ln>
-        </p:spPr>
-        <p:style>
-          <a:lnRef idx="1">
-            <a:schemeClr val="accent1"/>
-          </a:lnRef>
-          <a:fillRef idx="0">
-            <a:schemeClr val="accent1"/>
-          </a:fillRef>
-          <a:effectRef idx="0">
-            <a:schemeClr val="accent1"/>
-          </a:effectRef>
-          <a:fontRef idx="minor">
-            <a:schemeClr val="tx1"/>
-          </a:fontRef>
-        </p:style>
-      </p:cxnSp>
+        </p:nvSpPr>
+        <p:spPr/>
+        <p:txBody>
+          <a:bodyPr/>
+          <a:lstStyle/>
+          <a:p>
+            <a:r>
+              <a:rPr lang="en-GB" dirty="0"/>
+              <a:t>We’ve had analytical pipelines for years, but the aim of RAP is to:</a:t>
+            </a:r>
+          </a:p>
+          <a:p>
+            <a:pPr lvl="1"/>
+            <a:r>
+              <a:rPr lang="en-GB" dirty="0"/>
+              <a:t>Automate the parts of these pipelines that can be</a:t>
+            </a:r>
+          </a:p>
+          <a:p>
+            <a:pPr lvl="1"/>
+            <a:r>
+              <a:rPr lang="en-GB" dirty="0"/>
+              <a:t>Increase efficiency and accuracy</a:t>
+            </a:r>
+          </a:p>
+          <a:p>
+            <a:pPr lvl="1"/>
+            <a:r>
+              <a:rPr lang="en-GB" dirty="0"/>
+              <a:t>Create a clear audit trail to allow analyses to easily be re-run if needed </a:t>
+            </a:r>
+          </a:p>
+          <a:p>
+            <a:r>
+              <a:rPr lang="en-GB" dirty="0"/>
+              <a:t>This allows us to focus on the parts of our work where our human input can really add value</a:t>
+            </a:r>
+          </a:p>
+          <a:p>
+            <a:r>
+              <a:rPr lang="en-GB" dirty="0"/>
+              <a:t>RAP is something we can use to reduce the burden on us by getting rid of some of the boring stuff - what’s not to like!</a:t>
+            </a:r>
+          </a:p>
+        </p:txBody>
+      </p:sp>
     </p:spTree>
     <p:extLst>
       <p:ext uri="{BB962C8B-B14F-4D97-AF65-F5344CB8AC3E}">
-        <p14:creationId xmlns:p14="http://schemas.microsoft.com/office/powerpoint/2010/main" val="2713344255"/>
+        <p14:creationId xmlns:p14="http://schemas.microsoft.com/office/powerpoint/2010/main" val="1286926439"/>
       </p:ext>
     </p:extLst>
   </p:cSld>

</xml_diff>

<commit_message>
Reorder optional and supplementary sections for clarity, and update slides to match
</commit_message>
<xml_diff>
--- a/slides/workshopslides_RforRAP.pptx
+++ b/slides/workshopslides_RforRAP.pptx
@@ -3936,15 +3936,27 @@
           </a:p>
           <a:p>
             <a:r>
-              <a:rPr lang="en-GB" sz="6400" dirty="0"/>
+              <a:rPr lang="en-GB" sz="6400" dirty="0">
+                <a:solidFill>
+                  <a:srgbClr val="00B0F0"/>
+                </a:solidFill>
+              </a:rPr>
               <a:t>Using </a:t>
             </a:r>
             <a:r>
-              <a:rPr lang="en-GB" sz="6400" dirty="0" err="1"/>
+              <a:rPr lang="en-GB" sz="6400" dirty="0" err="1">
+                <a:solidFill>
+                  <a:srgbClr val="00B0F0"/>
+                </a:solidFill>
+              </a:rPr>
               <a:t>renv</a:t>
             </a:r>
             <a:r>
-              <a:rPr lang="en-GB" sz="6400" dirty="0"/>
+              <a:rPr lang="en-GB" sz="6400" dirty="0">
+                <a:solidFill>
+                  <a:srgbClr val="00B0F0"/>
+                </a:solidFill>
+              </a:rPr>
               <a:t> (optional) </a:t>
             </a:r>
           </a:p>
@@ -4402,41 +4414,76 @@
           </a:p>
           <a:p>
             <a:r>
-              <a:rPr lang="en-GB" sz="1600" dirty="0"/>
-              <a:t>Unit testing in R</a:t>
-            </a:r>
-          </a:p>
-          <a:p>
-            <a:r>
-              <a:rPr lang="en-GB" sz="1600" dirty="0" err="1"/>
+              <a:rPr lang="en-GB" sz="1600" dirty="0">
+                <a:solidFill>
+                  <a:srgbClr val="00B0F0"/>
+                </a:solidFill>
+              </a:rPr>
+              <a:t>Unit testing in R (optional)</a:t>
+            </a:r>
+          </a:p>
+          <a:p>
+            <a:r>
+              <a:rPr lang="en-GB" sz="1600" dirty="0">
+                <a:solidFill>
+                  <a:srgbClr val="00B0F0"/>
+                </a:solidFill>
+              </a:rPr>
+              <a:t>Accessing remote data (optional)</a:t>
+            </a:r>
+          </a:p>
+          <a:p>
+            <a:r>
+              <a:rPr lang="en-GB" sz="1600" i="1" dirty="0" err="1">
+                <a:solidFill>
+                  <a:srgbClr val="00B0F0"/>
+                </a:solidFill>
+              </a:rPr>
               <a:t>dplyr</a:t>
             </a:r>
             <a:r>
-              <a:rPr lang="en-GB" sz="1600" dirty="0"/>
+              <a:rPr lang="en-GB" sz="1600" i="1" dirty="0">
+                <a:solidFill>
+                  <a:srgbClr val="00B0F0"/>
+                </a:solidFill>
+              </a:rPr>
               <a:t> vs. </a:t>
             </a:r>
             <a:r>
-              <a:rPr lang="en-GB" sz="1600" dirty="0" err="1"/>
+              <a:rPr lang="en-GB" sz="1600" i="1" dirty="0" err="1">
+                <a:solidFill>
+                  <a:srgbClr val="00B0F0"/>
+                </a:solidFill>
+              </a:rPr>
               <a:t>data.table</a:t>
             </a:r>
-            <a:endParaRPr lang="en-GB" sz="1600" dirty="0"/>
-          </a:p>
-          <a:p>
-            <a:r>
-              <a:rPr lang="en-GB" sz="1600" dirty="0"/>
-              <a:t>Troubleshooting</a:t>
-            </a:r>
-          </a:p>
-          <a:p>
-            <a:r>
-              <a:rPr lang="en-GB" sz="1600" dirty="0"/>
-              <a:t>Excel functions in R</a:t>
-            </a:r>
-          </a:p>
-          <a:p>
-            <a:r>
-              <a:rPr lang="en-GB" sz="1600" dirty="0"/>
-              <a:t>Accessing remote data (optional)</a:t>
+            <a:r>
+              <a:rPr lang="en-GB" sz="1600" i="1" dirty="0">
+                <a:solidFill>
+                  <a:srgbClr val="00B0F0"/>
+                </a:solidFill>
+              </a:rPr>
+              <a:t> (supplementary)</a:t>
+            </a:r>
+          </a:p>
+          <a:p>
+            <a:r>
+              <a:rPr lang="en-GB" sz="1600" i="1" dirty="0">
+                <a:solidFill>
+                  <a:srgbClr val="00B0F0"/>
+                </a:solidFill>
+              </a:rPr>
+              <a:t>Troubleshooting (supplementary</a:t>
+            </a:r>
+          </a:p>
+          <a:p>
+            <a:r>
+              <a:rPr lang="en-GB" sz="1600" i="1" dirty="0">
+                <a:solidFill>
+                  <a:srgbClr val="00B0F0"/>
+                </a:solidFill>
+              </a:rPr>
+              <a:t>Excel functions in R (supplementary)</a:t>
             </a:r>
           </a:p>
         </p:txBody>

</xml_diff>